<commit_message>
Update mid-project deck: label-correction before/after, 2D/3D examples on clinical slide, takeaway box
</commit_message>
<xml_diff>
--- a/deck/midproject_outline.pptx
+++ b/deck/midproject_outline.pptx
@@ -2776,7 +2776,7 @@
         <p:spPr>
           <a:xfrm>
             <a:off x="640080" y="1783080"/>
-            <a:ext cx="10607040" cy="4206240"/>
+            <a:ext cx="3108960" cy="4206240"/>
           </a:xfrm>
           <a:prstGeom prst="rect">
             <a:avLst/>
@@ -2860,9 +2860,130 @@
           </a:p>
         </p:txBody>
       </p:sp>
+      <p:sp>
+        <p:nvSpPr>
+          <p:cNvPr id="8" name="Shape 6"/>
+          <p:cNvSpPr/>
+          <p:nvPr/>
+        </p:nvSpPr>
+        <p:spPr>
+          <a:xfrm>
+            <a:off x="640080" y="3931920"/>
+            <a:ext cx="3108960" cy="1188720"/>
+          </a:xfrm>
+          <a:prstGeom prst="rect">
+            <a:avLst/>
+          </a:prstGeom>
+          <a:solidFill>
+            <a:srgbClr val="F7E8EC"/>
+          </a:solidFill>
+          <a:ln/>
+        </p:spPr>
+      </p:sp>
+      <p:sp>
+        <p:nvSpPr>
+          <p:cNvPr id="9" name="Shape 7"/>
+          <p:cNvSpPr/>
+          <p:nvPr/>
+        </p:nvSpPr>
+        <p:spPr>
+          <a:xfrm>
+            <a:off x="640080" y="3931920"/>
+            <a:ext cx="54864" cy="1188720"/>
+          </a:xfrm>
+          <a:prstGeom prst="rect">
+            <a:avLst/>
+          </a:prstGeom>
+          <a:solidFill>
+            <a:srgbClr val="BC0031"/>
+          </a:solidFill>
+          <a:ln/>
+        </p:spPr>
+      </p:sp>
+      <p:sp>
+        <p:nvSpPr>
+          <p:cNvPr id="10" name="Text 8"/>
+          <p:cNvSpPr txBox="1"/>
+          <p:nvPr/>
+        </p:nvSpPr>
+        <p:spPr>
+          <a:xfrm>
+            <a:off x="914400" y="4114800"/>
+            <a:ext cx="2560320" cy="274320"/>
+          </a:xfrm>
+          <a:prstGeom prst="rect">
+            <a:avLst/>
+          </a:prstGeom>
+          <a:noFill/>
+          <a:ln/>
+        </p:spPr>
+        <p:txBody>
+          <a:bodyPr wrap="square" lIns="0" tIns="0" rIns="0" bIns="0" rtlCol="0" anchor="ctr"/>
+          <a:lstStyle/>
+          <a:p>
+            <a:pPr indent="0" marL="0">
+              <a:buNone/>
+            </a:pPr>
+            <a:r>
+              <a:rPr lang="en-US" sz="1100" b="1" spc="100" kern="0" dirty="0">
+                <a:solidFill>
+                  <a:srgbClr val="BC0031"/>
+                </a:solidFill>
+                <a:latin typeface="Times New Roman" pitchFamily="34" charset="0"/>
+                <a:ea typeface="Times New Roman" pitchFamily="34" charset="-122"/>
+                <a:cs typeface="Times New Roman" pitchFamily="34" charset="-120"/>
+              </a:rPr>
+              <a:t>TAKEAWAY</a:t>
+            </a:r>
+            <a:endParaRPr lang="en-US" sz="1100" dirty="0"/>
+          </a:p>
+        </p:txBody>
+      </p:sp>
+      <p:sp>
+        <p:nvSpPr>
+          <p:cNvPr id="11" name="Text 9"/>
+          <p:cNvSpPr txBox="1"/>
+          <p:nvPr/>
+        </p:nvSpPr>
+        <p:spPr>
+          <a:xfrm>
+            <a:off x="914400" y="4434840"/>
+            <a:ext cx="2560320" cy="502920"/>
+          </a:xfrm>
+          <a:prstGeom prst="rect">
+            <a:avLst/>
+          </a:prstGeom>
+          <a:noFill/>
+          <a:ln/>
+        </p:spPr>
+        <p:txBody>
+          <a:bodyPr wrap="square" lIns="0" tIns="0" rIns="0" bIns="0" rtlCol="0" anchor="t"/>
+          <a:lstStyle/>
+          <a:p>
+            <a:pPr indent="0" marL="0">
+              <a:lnSpc>
+                <a:spcPct val="118000"/>
+              </a:lnSpc>
+              <a:buNone/>
+            </a:pPr>
+            <a:r>
+              <a:rPr lang="en-US" sz="1350" dirty="0">
+                <a:solidFill>
+                  <a:srgbClr val="1F1D21"/>
+                </a:solidFill>
+                <a:latin typeface="Times New Roman" pitchFamily="34" charset="0"/>
+                <a:ea typeface="Times New Roman" pitchFamily="34" charset="-122"/>
+                <a:cs typeface="Times New Roman" pitchFamily="34" charset="-120"/>
+              </a:rPr>
+              <a:t>[TODO] one-sentence clinical takeaway</a:t>
+            </a:r>
+            <a:endParaRPr lang="en-US" sz="1350" dirty="0"/>
+          </a:p>
+        </p:txBody>
+      </p:sp>
       <p:pic>
         <p:nvPicPr>
-          <p:cNvPr id="8" name="Image 0" descr="/Users/bellavg/ProjectsMSc/ai4mi_project/.claude/worktrees/segthor-presentation-midpoint-825c66/deck/assets/uva_logo.png">    </p:cNvPr>
+          <p:cNvPr id="12" name="Image 0" descr="/Users/bellavg/ProjectsMSc/ai4mi_project/.claude/worktrees/segthor-presentation-midpoint-825c66/figures/comparison/label_example_2D.png">    </p:cNvPr>
           <p:cNvPicPr>
             <a:picLocks noChangeAspect="1"/>
           </p:cNvPicPr>
@@ -2870,6 +2991,91 @@
         </p:nvPicPr>
         <p:blipFill>
           <a:blip r:embed="rId1"/>
+          <a:srcRect l="0" r="0" t="0" b="0"/>
+          <a:stretch/>
+        </p:blipFill>
+        <p:spPr>
+          <a:xfrm>
+            <a:off x="4114800" y="1783080"/>
+            <a:ext cx="5010614" cy="3617186"/>
+          </a:xfrm>
+          <a:prstGeom prst="rect">
+            <a:avLst/>
+          </a:prstGeom>
+        </p:spPr>
+      </p:pic>
+      <p:pic>
+        <p:nvPicPr>
+          <p:cNvPr id="13" name="Image 1" descr="/Users/bellavg/ProjectsMSc/ai4mi_project/.claude/worktrees/segthor-presentation-midpoint-825c66/figures/comparison/label_example_3D.png">    </p:cNvPr>
+          <p:cNvPicPr>
+            <a:picLocks noChangeAspect="1"/>
+          </p:cNvPicPr>
+          <p:nvPr/>
+        </p:nvPicPr>
+        <p:blipFill>
+          <a:blip r:embed="rId2"/>
+          <a:srcRect l="0" r="0" t="0" b="0"/>
+          <a:stretch/>
+        </p:blipFill>
+        <p:spPr>
+          <a:xfrm>
+            <a:off x="9280862" y="1783080"/>
+            <a:ext cx="2268010" cy="3617186"/>
+          </a:xfrm>
+          <a:prstGeom prst="rect">
+            <a:avLst/>
+          </a:prstGeom>
+        </p:spPr>
+      </p:pic>
+      <p:sp>
+        <p:nvSpPr>
+          <p:cNvPr id="14" name="Text 10"/>
+          <p:cNvSpPr txBox="1"/>
+          <p:nvPr/>
+        </p:nvSpPr>
+        <p:spPr>
+          <a:xfrm>
+            <a:off x="4114800" y="5509994"/>
+            <a:ext cx="7434072" cy="320040"/>
+          </a:xfrm>
+          <a:prstGeom prst="rect">
+            <a:avLst/>
+          </a:prstGeom>
+          <a:noFill/>
+          <a:ln/>
+        </p:spPr>
+        <p:txBody>
+          <a:bodyPr wrap="square" lIns="0" tIns="0" rIns="0" bIns="0" rtlCol="0" anchor="ctr"/>
+          <a:lstStyle/>
+          <a:p>
+            <a:pPr indent="0" marL="0">
+              <a:buNone/>
+            </a:pPr>
+            <a:r>
+              <a:rPr lang="en-US" sz="1100" i="1" dirty="0">
+                <a:solidFill>
+                  <a:srgbClr val="6B6B6B"/>
+                </a:solidFill>
+                <a:latin typeface="Times New Roman" pitchFamily="34" charset="0"/>
+                <a:ea typeface="Times New Roman" pitchFamily="34" charset="-122"/>
+                <a:cs typeface="Times New Roman" pitchFamily="34" charset="-120"/>
+              </a:rPr>
+              <a:t>Patient_18: the four organs to segment, as an axial slice (102 of 183) and as 3D surfaces</a:t>
+            </a:r>
+            <a:endParaRPr lang="en-US" sz="1100" dirty="0"/>
+          </a:p>
+        </p:txBody>
+      </p:sp>
+      <p:pic>
+        <p:nvPicPr>
+          <p:cNvPr id="15" name="Image 2" descr="/Users/bellavg/ProjectsMSc/ai4mi_project/.claude/worktrees/segthor-presentation-midpoint-825c66/deck/assets/uva_logo.png">    </p:cNvPr>
+          <p:cNvPicPr>
+            <a:picLocks noChangeAspect="1"/>
+          </p:cNvPicPr>
+          <p:nvPr/>
+        </p:nvPicPr>
+        <p:blipFill>
+          <a:blip r:embed="rId3"/>
           <a:stretch>
             <a:fillRect/>
           </a:stretch>
@@ -2886,7 +3092,7 @@
       </p:pic>
       <p:sp>
         <p:nvSpPr>
-          <p:cNvPr id="9" name="Text 6"/>
+          <p:cNvPr id="16" name="Text 11"/>
           <p:cNvSpPr txBox="1"/>
           <p:nvPr/>
         </p:nvSpPr>
@@ -3062,7 +3268,7 @@
         <p:spPr>
           <a:xfrm>
             <a:off x="640080" y="658368"/>
-            <a:ext cx="10881360" cy="502920"/>
+            <a:ext cx="10881360" cy="822960"/>
           </a:xfrm>
           <a:prstGeom prst="rect">
             <a:avLst/>
@@ -3092,38 +3298,35 @@
           </a:p>
         </p:txBody>
       </p:sp>
-      <p:pic>
-        <p:nvPicPr>
-          <p:cNvPr id="6" name="Image 0" descr="/Users/bellavg/ProjectsMSc/ai4mi_project/.claude/worktrees/segthor-presentation-midpoint-825c66/figures/comparison/connected_components.png">    </p:cNvPr>
-          <p:cNvPicPr>
-            <a:picLocks noChangeAspect="1"/>
-          </p:cNvPicPr>
-          <p:nvPr/>
-        </p:nvPicPr>
-        <p:blipFill>
-          <a:blip r:embed="rId1"/>
-          <a:srcRect l="0" r="0" t="0" b="0"/>
-          <a:stretch/>
-        </p:blipFill>
-        <p:spPr>
-          <a:xfrm>
-            <a:off x="4114800" y="1234440"/>
-            <a:ext cx="7434072" cy="3382503"/>
-          </a:xfrm>
-          <a:prstGeom prst="rect">
-            <a:avLst/>
-          </a:prstGeom>
-        </p:spPr>
-      </p:pic>
-      <p:sp>
-        <p:nvSpPr>
-          <p:cNvPr id="7" name="Text 4"/>
-          <p:cNvSpPr txBox="1"/>
-          <p:nvPr/>
-        </p:nvSpPr>
-        <p:spPr>
-          <a:xfrm>
-            <a:off x="640080" y="1234440"/>
+      <p:sp>
+        <p:nvSpPr>
+          <p:cNvPr id="6" name="Shape 4"/>
+          <p:cNvSpPr/>
+          <p:nvPr/>
+        </p:nvSpPr>
+        <p:spPr>
+          <a:xfrm>
+            <a:off x="658368" y="1463040"/>
+            <a:ext cx="1005840" cy="32004"/>
+          </a:xfrm>
+          <a:prstGeom prst="rect">
+            <a:avLst/>
+          </a:prstGeom>
+          <a:solidFill>
+            <a:srgbClr val="BC0031"/>
+          </a:solidFill>
+          <a:ln/>
+        </p:spPr>
+      </p:sp>
+      <p:sp>
+        <p:nvSpPr>
+          <p:cNvPr id="7" name="Text 5"/>
+          <p:cNvSpPr txBox="1"/>
+          <p:nvPr/>
+        </p:nvSpPr>
+        <p:spPr>
+          <a:xfrm>
+            <a:off x="640080" y="1783080"/>
             <a:ext cx="3108960" cy="256032"/>
           </a:xfrm>
           <a:prstGeom prst="rect">
@@ -3156,14 +3359,14 @@
       </p:sp>
       <p:sp>
         <p:nvSpPr>
-          <p:cNvPr id="8" name="Text 5"/>
-          <p:cNvSpPr txBox="1"/>
-          <p:nvPr/>
-        </p:nvSpPr>
-        <p:spPr>
-          <a:xfrm>
-            <a:off x="640080" y="1527048"/>
-            <a:ext cx="3108960" cy="1164717"/>
+          <p:cNvPr id="8" name="Text 6"/>
+          <p:cNvSpPr txBox="1"/>
+          <p:nvPr/>
+        </p:nvSpPr>
+        <p:spPr>
+          <a:xfrm>
+            <a:off x="640080" y="2075688"/>
+            <a:ext cx="3108960" cy="1046988"/>
           </a:xfrm>
           <a:prstGeom prst="rect">
             <a:avLst/>
@@ -3194,7 +3397,7 @@
                 <a:ea typeface="Times New Roman" pitchFamily="34" charset="-122"/>
                 <a:cs typeface="Times New Roman" pitchFamily="34" charset="-120"/>
               </a:rPr>
-              <a:t>Connected pieces per label, for all patients: % of axial slices (2D) or patients (3D) with 1, 2 or 3+ pieces</a:t>
+              <a:t>Patient_02: axial slice 111 and 3D view</a:t>
             </a:r>
             <a:endParaRPr lang="en-US" sz="1250" dirty="0"/>
           </a:p>
@@ -3218,71 +3421,10 @@
                 <a:ea typeface="Times New Roman" pitchFamily="34" charset="-122"/>
                 <a:cs typeface="Times New Roman" pitchFamily="34" charset="-120"/>
               </a:rPr>
-              <a:t>Top: aorta merged (3 labels). Bottom: aorta separate (4 labels)</a:t>
+              <a:t>Before: two pieces carry the esophagus label</a:t>
             </a:r>
             <a:endParaRPr lang="en-US" sz="1250" dirty="0"/>
           </a:p>
-        </p:txBody>
-      </p:sp>
-      <p:sp>
-        <p:nvSpPr>
-          <p:cNvPr id="9" name="Text 6"/>
-          <p:cNvSpPr txBox="1"/>
-          <p:nvPr/>
-        </p:nvSpPr>
-        <p:spPr>
-          <a:xfrm>
-            <a:off x="640080" y="2920365"/>
-            <a:ext cx="3108960" cy="256032"/>
-          </a:xfrm>
-          <a:prstGeom prst="rect">
-            <a:avLst/>
-          </a:prstGeom>
-          <a:noFill/>
-          <a:ln/>
-        </p:spPr>
-        <p:txBody>
-          <a:bodyPr wrap="square" lIns="0" tIns="0" rIns="0" bIns="0" rtlCol="0" anchor="ctr"/>
-          <a:lstStyle/>
-          <a:p>
-            <a:pPr indent="0" marL="0">
-              <a:buNone/>
-            </a:pPr>
-            <a:r>
-              <a:rPr lang="en-US" sz="1150" b="1" spc="100" kern="0" dirty="0">
-                <a:solidFill>
-                  <a:srgbClr val="BC0031"/>
-                </a:solidFill>
-                <a:latin typeface="Times New Roman" pitchFamily="34" charset="0"/>
-                <a:ea typeface="Times New Roman" pitchFamily="34" charset="-122"/>
-                <a:cs typeface="Times New Roman" pitchFamily="34" charset="-120"/>
-              </a:rPr>
-              <a:t>VALIDATION</a:t>
-            </a:r>
-            <a:endParaRPr lang="en-US" sz="1150" dirty="0"/>
-          </a:p>
-        </p:txBody>
-      </p:sp>
-      <p:sp>
-        <p:nvSpPr>
-          <p:cNvPr id="10" name="Text 7"/>
-          <p:cNvSpPr txBox="1"/>
-          <p:nvPr/>
-        </p:nvSpPr>
-        <p:spPr>
-          <a:xfrm>
-            <a:off x="640080" y="3212973"/>
-            <a:ext cx="3108960" cy="1729359"/>
-          </a:xfrm>
-          <a:prstGeom prst="rect">
-            <a:avLst/>
-          </a:prstGeom>
-          <a:noFill/>
-          <a:ln/>
-        </p:spPr>
-        <p:txBody>
-          <a:bodyPr wrap="square" lIns="0" tIns="0" rIns="0" bIns="0" rtlCol="0" anchor="t"/>
-          <a:lstStyle/>
           <a:p>
             <a:pPr marL="177800" indent="-177800">
               <a:lnSpc>
@@ -3303,10 +3445,71 @@
                 <a:ea typeface="Times New Roman" pitchFamily="34" charset="-122"/>
                 <a:cs typeface="Times New Roman" pitchFamily="34" charset="-120"/>
               </a:rPr>
-              <a:t>[TODO] how the mislabeling was found and fixed</a:t>
+              <a:t>After: one piece relabelled aorta</a:t>
             </a:r>
             <a:endParaRPr lang="en-US" sz="1250" dirty="0"/>
           </a:p>
+        </p:txBody>
+      </p:sp>
+      <p:sp>
+        <p:nvSpPr>
+          <p:cNvPr id="9" name="Text 7"/>
+          <p:cNvSpPr txBox="1"/>
+          <p:nvPr/>
+        </p:nvSpPr>
+        <p:spPr>
+          <a:xfrm>
+            <a:off x="640080" y="3351276"/>
+            <a:ext cx="3108960" cy="256032"/>
+          </a:xfrm>
+          <a:prstGeom prst="rect">
+            <a:avLst/>
+          </a:prstGeom>
+          <a:noFill/>
+          <a:ln/>
+        </p:spPr>
+        <p:txBody>
+          <a:bodyPr wrap="square" lIns="0" tIns="0" rIns="0" bIns="0" rtlCol="0" anchor="ctr"/>
+          <a:lstStyle/>
+          <a:p>
+            <a:pPr indent="0" marL="0">
+              <a:buNone/>
+            </a:pPr>
+            <a:r>
+              <a:rPr lang="en-US" sz="1150" b="1" spc="100" kern="0" dirty="0">
+                <a:solidFill>
+                  <a:srgbClr val="BC0031"/>
+                </a:solidFill>
+                <a:latin typeface="Times New Roman" pitchFamily="34" charset="0"/>
+                <a:ea typeface="Times New Roman" pitchFamily="34" charset="-122"/>
+                <a:cs typeface="Times New Roman" pitchFamily="34" charset="-120"/>
+              </a:rPr>
+              <a:t>VALIDATION</a:t>
+            </a:r>
+            <a:endParaRPr lang="en-US" sz="1150" dirty="0"/>
+          </a:p>
+        </p:txBody>
+      </p:sp>
+      <p:sp>
+        <p:nvSpPr>
+          <p:cNvPr id="10" name="Text 8"/>
+          <p:cNvSpPr txBox="1"/>
+          <p:nvPr/>
+        </p:nvSpPr>
+        <p:spPr>
+          <a:xfrm>
+            <a:off x="640080" y="3643884"/>
+            <a:ext cx="3108960" cy="1729359"/>
+          </a:xfrm>
+          <a:prstGeom prst="rect">
+            <a:avLst/>
+          </a:prstGeom>
+          <a:noFill/>
+          <a:ln/>
+        </p:spPr>
+        <p:txBody>
+          <a:bodyPr wrap="square" lIns="0" tIns="0" rIns="0" bIns="0" rtlCol="0" anchor="t"/>
+          <a:lstStyle/>
           <a:p>
             <a:pPr marL="177800" indent="-177800">
               <a:lnSpc>
@@ -3327,7 +3530,7 @@
                 <a:ea typeface="Times New Roman" pitchFamily="34" charset="-122"/>
                 <a:cs typeface="Times New Roman" pitchFamily="34" charset="-120"/>
               </a:rPr>
-              <a:t>[TODO] real per-class voxel share, now corrected — as numbers, not a bar chart</a:t>
+              <a:t>[TODO] how the mislabeling was found and fixed</a:t>
             </a:r>
             <a:endParaRPr lang="en-US" sz="1250" dirty="0"/>
           </a:p>
@@ -3351,7 +3554,7 @@
                 <a:ea typeface="Times New Roman" pitchFamily="34" charset="-122"/>
                 <a:cs typeface="Times New Roman" pitchFamily="34" charset="-120"/>
               </a:rPr>
-              <a:t>[TODO] any other integrity checks run (e.g. alignment)</a:t>
+              <a:t>[TODO] real per-class voxel share, now corrected — as numbers, not a bar chart</a:t>
             </a:r>
             <a:endParaRPr lang="en-US" sz="1250" dirty="0"/>
           </a:p>
@@ -3375,6 +3578,30 @@
                 <a:ea typeface="Times New Roman" pitchFamily="34" charset="-122"/>
                 <a:cs typeface="Times New Roman" pitchFamily="34" charset="-120"/>
               </a:rPr>
+              <a:t>[TODO] any other integrity checks run (e.g. alignment)</a:t>
+            </a:r>
+            <a:endParaRPr lang="en-US" sz="1250" dirty="0"/>
+          </a:p>
+          <a:p>
+            <a:pPr marL="177800" indent="-177800">
+              <a:lnSpc>
+                <a:spcPct val="115000"/>
+              </a:lnSpc>
+              <a:spcAft>
+                <a:spcPts val="500"/>
+              </a:spcAft>
+              <a:buSzPct val="100000"/>
+              <a:buChar char="▪"/>
+            </a:pPr>
+            <a:r>
+              <a:rPr lang="en-US" sz="1250" dirty="0">
+                <a:solidFill>
+                  <a:srgbClr val="1F1D21"/>
+                </a:solidFill>
+                <a:latin typeface="Times New Roman" pitchFamily="34" charset="0"/>
+                <a:ea typeface="Times New Roman" pitchFamily="34" charset="-122"/>
+                <a:cs typeface="Times New Roman" pitchFamily="34" charset="-120"/>
+              </a:rPr>
               <a:t>[TODO] fragmentation risk, if any</a:t>
             </a:r>
             <a:endParaRPr lang="en-US" sz="1250" dirty="0"/>
@@ -3383,13 +3610,157 @@
       </p:sp>
       <p:sp>
         <p:nvSpPr>
-          <p:cNvPr id="11" name="Shape 8"/>
+          <p:cNvPr id="11" name="Text 9"/>
+          <p:cNvSpPr txBox="1"/>
+          <p:nvPr/>
+        </p:nvSpPr>
+        <p:spPr>
+          <a:xfrm>
+            <a:off x="4114800" y="1783080"/>
+            <a:ext cx="3374136" cy="256032"/>
+          </a:xfrm>
+          <a:prstGeom prst="rect">
+            <a:avLst/>
+          </a:prstGeom>
+          <a:noFill/>
+          <a:ln/>
+        </p:spPr>
+        <p:txBody>
+          <a:bodyPr wrap="square" lIns="0" tIns="0" rIns="0" bIns="0" rtlCol="0" anchor="ctr"/>
+          <a:lstStyle/>
+          <a:p>
+            <a:pPr indent="0" marL="0">
+              <a:buNone/>
+            </a:pPr>
+            <a:r>
+              <a:rPr lang="en-US" sz="1150" b="1" spc="100" kern="0" dirty="0">
+                <a:solidFill>
+                  <a:srgbClr val="6B6B6B"/>
+                </a:solidFill>
+                <a:latin typeface="Times New Roman" pitchFamily="34" charset="0"/>
+                <a:ea typeface="Times New Roman" pitchFamily="34" charset="-122"/>
+                <a:cs typeface="Times New Roman" pitchFamily="34" charset="-120"/>
+              </a:rPr>
+              <a:t>BEFORE</a:t>
+            </a:r>
+            <a:endParaRPr lang="en-US" sz="1150" dirty="0"/>
+          </a:p>
+        </p:txBody>
+      </p:sp>
+      <p:pic>
+        <p:nvPicPr>
+          <p:cNvPr id="12" name="Image 0" descr="/Users/bellavg/ProjectsMSc/ai4mi_project/.claude/worktrees/segthor-presentation-midpoint-825c66/figures/comparison/label_correction_example_before.png">    </p:cNvPr>
+          <p:cNvPicPr>
+            <a:picLocks noChangeAspect="1"/>
+          </p:cNvPicPr>
+          <p:nvPr/>
+        </p:nvPicPr>
+        <p:blipFill>
+          <a:blip r:embed="rId1"/>
+          <a:srcRect l="0" r="0" t="0" b="0"/>
+          <a:stretch/>
+        </p:blipFill>
+        <p:spPr>
+          <a:xfrm>
+            <a:off x="4114800" y="2148840"/>
+            <a:ext cx="3374136" cy="1872044"/>
+          </a:xfrm>
+          <a:prstGeom prst="rect">
+            <a:avLst/>
+          </a:prstGeom>
+        </p:spPr>
+      </p:pic>
+      <p:sp>
+        <p:nvSpPr>
+          <p:cNvPr id="13" name="Text 10"/>
+          <p:cNvSpPr txBox="1"/>
+          <p:nvPr/>
+        </p:nvSpPr>
+        <p:spPr>
+          <a:xfrm>
+            <a:off x="8174736" y="1783080"/>
+            <a:ext cx="3374136" cy="256032"/>
+          </a:xfrm>
+          <a:prstGeom prst="rect">
+            <a:avLst/>
+          </a:prstGeom>
+          <a:noFill/>
+          <a:ln/>
+        </p:spPr>
+        <p:txBody>
+          <a:bodyPr wrap="square" lIns="0" tIns="0" rIns="0" bIns="0" rtlCol="0" anchor="ctr"/>
+          <a:lstStyle/>
+          <a:p>
+            <a:pPr indent="0" marL="0">
+              <a:buNone/>
+            </a:pPr>
+            <a:r>
+              <a:rPr lang="en-US" sz="1150" b="1" spc="100" kern="0" dirty="0">
+                <a:solidFill>
+                  <a:srgbClr val="BC0031"/>
+                </a:solidFill>
+                <a:latin typeface="Times New Roman" pitchFamily="34" charset="0"/>
+                <a:ea typeface="Times New Roman" pitchFamily="34" charset="-122"/>
+                <a:cs typeface="Times New Roman" pitchFamily="34" charset="-120"/>
+              </a:rPr>
+              <a:t>AFTER</a:t>
+            </a:r>
+            <a:endParaRPr lang="en-US" sz="1150" dirty="0"/>
+          </a:p>
+        </p:txBody>
+      </p:sp>
+      <p:pic>
+        <p:nvPicPr>
+          <p:cNvPr id="14" name="Image 1" descr="/Users/bellavg/ProjectsMSc/ai4mi_project/.claude/worktrees/segthor-presentation-midpoint-825c66/figures/comparison/label_correction_example_after.png">    </p:cNvPr>
+          <p:cNvPicPr>
+            <a:picLocks noChangeAspect="1"/>
+          </p:cNvPicPr>
+          <p:nvPr/>
+        </p:nvPicPr>
+        <p:blipFill>
+          <a:blip r:embed="rId2"/>
+          <a:srcRect l="0" r="0" t="0" b="0"/>
+          <a:stretch/>
+        </p:blipFill>
+        <p:spPr>
+          <a:xfrm>
+            <a:off x="8174736" y="2148840"/>
+            <a:ext cx="3374136" cy="1872044"/>
+          </a:xfrm>
+          <a:prstGeom prst="rect">
+            <a:avLst/>
+          </a:prstGeom>
+        </p:spPr>
+      </p:pic>
+      <p:sp>
+        <p:nvSpPr>
+          <p:cNvPr id="15" name="Shape 11"/>
           <p:cNvSpPr/>
           <p:nvPr/>
         </p:nvSpPr>
         <p:spPr>
           <a:xfrm>
-            <a:off x="4114800" y="4891263"/>
+            <a:off x="7603236" y="2947702"/>
+            <a:ext cx="457200" cy="274320"/>
+          </a:xfrm>
+          <a:prstGeom prst="rightArrow">
+            <a:avLst/>
+          </a:prstGeom>
+          <a:solidFill>
+            <a:srgbClr val="BC0031"/>
+          </a:solidFill>
+          <a:ln/>
+        </p:spPr>
+      </p:sp>
+      <p:sp>
+        <p:nvSpPr>
+          <p:cNvPr id="16" name="Shape 12"/>
+          <p:cNvSpPr/>
+          <p:nvPr/>
+        </p:nvSpPr>
+        <p:spPr>
+          <a:xfrm>
+            <a:off x="4114800" y="4340924"/>
             <a:ext cx="7434072" cy="1143000"/>
           </a:xfrm>
           <a:prstGeom prst="rect">
@@ -3403,13 +3774,13 @@
       </p:sp>
       <p:sp>
         <p:nvSpPr>
-          <p:cNvPr id="12" name="Shape 9"/>
+          <p:cNvPr id="17" name="Shape 13"/>
           <p:cNvSpPr/>
           <p:nvPr/>
         </p:nvSpPr>
         <p:spPr>
           <a:xfrm>
-            <a:off x="4114800" y="4891263"/>
+            <a:off x="4114800" y="4340924"/>
             <a:ext cx="54864" cy="1143000"/>
           </a:xfrm>
           <a:prstGeom prst="rect">
@@ -3423,13 +3794,13 @@
       </p:sp>
       <p:sp>
         <p:nvSpPr>
-          <p:cNvPr id="13" name="Text 10"/>
-          <p:cNvSpPr txBox="1"/>
-          <p:nvPr/>
-        </p:nvSpPr>
-        <p:spPr>
-          <a:xfrm>
-            <a:off x="4389120" y="5074143"/>
+          <p:cNvPr id="18" name="Text 14"/>
+          <p:cNvSpPr txBox="1"/>
+          <p:nvPr/>
+        </p:nvSpPr>
+        <p:spPr>
+          <a:xfrm>
+            <a:off x="4389120" y="4523804"/>
             <a:ext cx="6885432" cy="274320"/>
           </a:xfrm>
           <a:prstGeom prst="rect">
@@ -3462,13 +3833,13 @@
       </p:sp>
       <p:sp>
         <p:nvSpPr>
-          <p:cNvPr id="14" name="Text 11"/>
-          <p:cNvSpPr txBox="1"/>
-          <p:nvPr/>
-        </p:nvSpPr>
-        <p:spPr>
-          <a:xfrm>
-            <a:off x="4389120" y="5394183"/>
+          <p:cNvPr id="19" name="Text 15"/>
+          <p:cNvSpPr txBox="1"/>
+          <p:nvPr/>
+        </p:nvSpPr>
+        <p:spPr>
+          <a:xfrm>
+            <a:off x="4389120" y="4843844"/>
             <a:ext cx="6885432" cy="457200"/>
           </a:xfrm>
           <a:prstGeom prst="rect">
@@ -3504,14 +3875,14 @@
       </p:sp>
       <p:pic>
         <p:nvPicPr>
-          <p:cNvPr id="15" name="Image 1" descr="/Users/bellavg/ProjectsMSc/ai4mi_project/.claude/worktrees/segthor-presentation-midpoint-825c66/deck/assets/uva_logo.png">    </p:cNvPr>
+          <p:cNvPr id="20" name="Image 2" descr="/Users/bellavg/ProjectsMSc/ai4mi_project/.claude/worktrees/segthor-presentation-midpoint-825c66/deck/assets/uva_logo.png">    </p:cNvPr>
           <p:cNvPicPr>
             <a:picLocks noChangeAspect="1"/>
           </p:cNvPicPr>
           <p:nvPr/>
         </p:nvPicPr>
         <p:blipFill>
-          <a:blip r:embed="rId2"/>
+          <a:blip r:embed="rId3"/>
           <a:stretch>
             <a:fillRect/>
           </a:stretch>
@@ -3528,7 +3899,7 @@
       </p:pic>
       <p:sp>
         <p:nvSpPr>
-          <p:cNvPr id="16" name="Text 12"/>
+          <p:cNvPr id="21" name="Text 16"/>
           <p:cNvSpPr txBox="1"/>
           <p:nvPr/>
         </p:nvSpPr>

</xml_diff>

<commit_message>
Deck: grey takeaway box on clinical slide
</commit_message>
<xml_diff>
--- a/deck/midproject_outline.pptx
+++ b/deck/midproject_outline.pptx
@@ -2875,7 +2875,7 @@
             <a:avLst/>
           </a:prstGeom>
           <a:solidFill>
-            <a:srgbClr val="F7E8EC"/>
+            <a:srgbClr val="F0F0F0"/>
           </a:solidFill>
           <a:ln/>
         </p:spPr>
@@ -2895,7 +2895,7 @@
             <a:avLst/>
           </a:prstGeom>
           <a:solidFill>
-            <a:srgbClr val="BC0031"/>
+            <a:srgbClr val="1F1D21"/>
           </a:solidFill>
           <a:ln/>
         </p:spPr>
@@ -2927,7 +2927,7 @@
             <a:r>
               <a:rPr lang="en-US" sz="1100" b="1" spc="100" kern="0" dirty="0">
                 <a:solidFill>
-                  <a:srgbClr val="BC0031"/>
+                  <a:srgbClr val="1F1D21"/>
                 </a:solidFill>
                 <a:latin typeface="Times New Roman" pitchFamily="34" charset="0"/>
                 <a:ea typeface="Times New Roman" pitchFamily="34" charset="-122"/>

</xml_diff>

<commit_message>
Deck: make-up rings and connected components side by side on validation slide
</commit_message>
<xml_diff>
--- a/deck/midproject_outline.pptx
+++ b/deck/midproject_outline.pptx
@@ -4279,16 +4279,39 @@
           <a:ln/>
         </p:spPr>
       </p:sp>
-      <p:sp>
-        <p:nvSpPr>
-          <p:cNvPr id="7" name="Text 5"/>
-          <p:cNvSpPr txBox="1"/>
-          <p:nvPr/>
-        </p:nvSpPr>
+      <p:pic>
+        <p:nvPicPr>
+          <p:cNvPr id="7" name="Image 0" descr="/Users/bellavg/ProjectsMSc/ai4mi_project/.claude/worktrees/segthor-presentation-midpoint-825c66/figures/comparison/label_makeup_rings.png">    </p:cNvPr>
+          <p:cNvPicPr>
+            <a:picLocks noChangeAspect="1"/>
+          </p:cNvPicPr>
+          <p:nvPr/>
+        </p:nvPicPr>
+        <p:blipFill>
+          <a:blip r:embed="rId1"/>
+          <a:srcRect l="0" r="0" t="0" b="0"/>
+          <a:stretch/>
+        </p:blipFill>
         <p:spPr>
           <a:xfrm>
             <a:off x="640080" y="1645920"/>
-            <a:ext cx="4233672" cy="256032"/>
+            <a:ext cx="4206240" cy="2196592"/>
+          </a:xfrm>
+          <a:prstGeom prst="rect">
+            <a:avLst/>
+          </a:prstGeom>
+        </p:spPr>
+      </p:pic>
+      <p:sp>
+        <p:nvSpPr>
+          <p:cNvPr id="8" name="Text 5"/>
+          <p:cNvSpPr txBox="1"/>
+          <p:nvPr/>
+        </p:nvSpPr>
+        <p:spPr>
+          <a:xfrm>
+            <a:off x="640080" y="3952240"/>
+            <a:ext cx="4828032" cy="256032"/>
           </a:xfrm>
           <a:prstGeom prst="rect">
             <a:avLst/>
@@ -4320,14 +4343,14 @@
       </p:sp>
       <p:sp>
         <p:nvSpPr>
-          <p:cNvPr id="8" name="Text 6"/>
-          <p:cNvSpPr txBox="1"/>
-          <p:nvPr/>
-        </p:nvSpPr>
-        <p:spPr>
-          <a:xfrm>
-            <a:off x="640080" y="1938528"/>
-            <a:ext cx="4233672" cy="482346"/>
+          <p:cNvPr id="9" name="Text 6"/>
+          <p:cNvSpPr txBox="1"/>
+          <p:nvPr/>
+        </p:nvSpPr>
+        <p:spPr>
+          <a:xfrm>
+            <a:off x="640080" y="4244848"/>
+            <a:ext cx="4828032" cy="964692"/>
           </a:xfrm>
           <a:prstGeom prst="rect">
             <a:avLst/>
@@ -4358,71 +4381,10 @@
                 <a:ea typeface="Times New Roman" pitchFamily="34" charset="-122"/>
                 <a:cs typeface="Times New Roman" pitchFamily="34" charset="-120"/>
               </a:rPr>
-              <a:t>[TODO] real per-class voxel share, now corrected — as numbers, not a bar chart</a:t>
+              <a:t>20 patients, 978 million voxels: 98.96% background, 1.04% labelled (10.2 M)</a:t>
             </a:r>
             <a:endParaRPr lang="en-US" sz="1250" dirty="0"/>
           </a:p>
-        </p:txBody>
-      </p:sp>
-      <p:sp>
-        <p:nvSpPr>
-          <p:cNvPr id="9" name="Text 7"/>
-          <p:cNvSpPr txBox="1"/>
-          <p:nvPr/>
-        </p:nvSpPr>
-        <p:spPr>
-          <a:xfrm>
-            <a:off x="640080" y="2649474"/>
-            <a:ext cx="4233672" cy="256032"/>
-          </a:xfrm>
-          <a:prstGeom prst="rect">
-            <a:avLst/>
-          </a:prstGeom>
-          <a:noFill/>
-          <a:ln/>
-        </p:spPr>
-        <p:txBody>
-          <a:bodyPr wrap="square" lIns="0" tIns="0" rIns="0" bIns="0" rtlCol="0" anchor="ctr"/>
-          <a:lstStyle/>
-          <a:p>
-            <a:pPr indent="0" marL="0">
-              <a:buNone/>
-            </a:pPr>
-            <a:r>
-              <a:rPr lang="en-US" sz="1150" b="1" spc="100" kern="0" dirty="0">
-                <a:solidFill>
-                  <a:srgbClr val="BC0031"/>
-                </a:solidFill>
-                <a:latin typeface="Times New Roman" pitchFamily="34" charset="0"/>
-                <a:ea typeface="Times New Roman" pitchFamily="34" charset="-122"/>
-                <a:cs typeface="Times New Roman" pitchFamily="34" charset="-120"/>
-              </a:rPr>
-              <a:t>CONNECTED COMPONENTS</a:t>
-            </a:r>
-            <a:endParaRPr lang="en-US" sz="1150" dirty="0"/>
-          </a:p>
-        </p:txBody>
-      </p:sp>
-      <p:sp>
-        <p:nvSpPr>
-          <p:cNvPr id="10" name="Text 8"/>
-          <p:cNvSpPr txBox="1"/>
-          <p:nvPr/>
-        </p:nvSpPr>
-        <p:spPr>
-          <a:xfrm>
-            <a:off x="640080" y="2942082"/>
-            <a:ext cx="4233672" cy="1247013"/>
-          </a:xfrm>
-          <a:prstGeom prst="rect">
-            <a:avLst/>
-          </a:prstGeom>
-          <a:noFill/>
-          <a:ln/>
-        </p:spPr>
-        <p:txBody>
-          <a:bodyPr wrap="square" lIns="0" tIns="0" rIns="0" bIns="0" rtlCol="0" anchor="t"/>
-          <a:lstStyle/>
           <a:p>
             <a:pPr marL="177800" indent="-177800">
               <a:lnSpc>
@@ -4443,10 +4405,94 @@
                 <a:ea typeface="Times New Roman" pitchFamily="34" charset="-122"/>
                 <a:cs typeface="Times New Roman" pitchFamily="34" charset="-120"/>
               </a:rPr>
-              <a:t>Connected pieces per label, for all patients: % of axial slices (2D) or patients (3D) with 1, 2 or 3+ pieces</a:t>
+              <a:t>Share of labelled voxels, 3 labels → 4 labels: esophagus 23.1% → 4.1%; aorta 18.9%</a:t>
             </a:r>
             <a:endParaRPr lang="en-US" sz="1250" dirty="0"/>
           </a:p>
+        </p:txBody>
+      </p:sp>
+      <p:pic>
+        <p:nvPicPr>
+          <p:cNvPr id="10" name="Image 1" descr="/Users/bellavg/ProjectsMSc/ai4mi_project/.claude/worktrees/segthor-presentation-midpoint-825c66/figures/comparison/connected_components.png">    </p:cNvPr>
+          <p:cNvPicPr>
+            <a:picLocks noChangeAspect="1"/>
+          </p:cNvPicPr>
+          <p:nvPr/>
+        </p:nvPicPr>
+        <p:blipFill>
+          <a:blip r:embed="rId2"/>
+          <a:srcRect l="0" r="0" t="0" b="0"/>
+          <a:stretch/>
+        </p:blipFill>
+        <p:spPr>
+          <a:xfrm>
+            <a:off x="6720840" y="1645920"/>
+            <a:ext cx="4206240" cy="2154416"/>
+          </a:xfrm>
+          <a:prstGeom prst="rect">
+            <a:avLst/>
+          </a:prstGeom>
+        </p:spPr>
+      </p:pic>
+      <p:sp>
+        <p:nvSpPr>
+          <p:cNvPr id="11" name="Text 7"/>
+          <p:cNvSpPr txBox="1"/>
+          <p:nvPr/>
+        </p:nvSpPr>
+        <p:spPr>
+          <a:xfrm>
+            <a:off x="6720840" y="3910064"/>
+            <a:ext cx="4828032" cy="256032"/>
+          </a:xfrm>
+          <a:prstGeom prst="rect">
+            <a:avLst/>
+          </a:prstGeom>
+          <a:noFill/>
+          <a:ln/>
+        </p:spPr>
+        <p:txBody>
+          <a:bodyPr wrap="square" lIns="0" tIns="0" rIns="0" bIns="0" rtlCol="0" anchor="ctr"/>
+          <a:lstStyle/>
+          <a:p>
+            <a:pPr indent="0" marL="0">
+              <a:buNone/>
+            </a:pPr>
+            <a:r>
+              <a:rPr lang="en-US" sz="1150" b="1" spc="100" kern="0" dirty="0">
+                <a:solidFill>
+                  <a:srgbClr val="BC0031"/>
+                </a:solidFill>
+                <a:latin typeface="Times New Roman" pitchFamily="34" charset="0"/>
+                <a:ea typeface="Times New Roman" pitchFamily="34" charset="-122"/>
+                <a:cs typeface="Times New Roman" pitchFamily="34" charset="-120"/>
+              </a:rPr>
+              <a:t>CONNECTED COMPONENTS</a:t>
+            </a:r>
+            <a:endParaRPr lang="en-US" sz="1150" dirty="0"/>
+          </a:p>
+        </p:txBody>
+      </p:sp>
+      <p:sp>
+        <p:nvSpPr>
+          <p:cNvPr id="12" name="Text 8"/>
+          <p:cNvSpPr txBox="1"/>
+          <p:nvPr/>
+        </p:nvSpPr>
+        <p:spPr>
+          <a:xfrm>
+            <a:off x="6720840" y="4202672"/>
+            <a:ext cx="4828032" cy="846963"/>
+          </a:xfrm>
+          <a:prstGeom prst="rect">
+            <a:avLst/>
+          </a:prstGeom>
+          <a:noFill/>
+          <a:ln/>
+        </p:spPr>
+        <p:txBody>
+          <a:bodyPr wrap="square" lIns="0" tIns="0" rIns="0" bIns="0" rtlCol="0" anchor="t"/>
+          <a:lstStyle/>
           <a:p>
             <a:pPr marL="177800" indent="-177800">
               <a:lnSpc>
@@ -4467,7 +4513,7 @@
                 <a:ea typeface="Times New Roman" pitchFamily="34" charset="-122"/>
                 <a:cs typeface="Times New Roman" pitchFamily="34" charset="-120"/>
               </a:rPr>
-              <a:t>Top: aorta merged (3 labels). Bottom: aorta separate (4 labels)</a:t>
+              <a:t>% of slices (2D) or patients (3D) with 1, 2 or 3+ pieces</a:t>
             </a:r>
             <a:endParaRPr lang="en-US" sz="1250" dirty="0"/>
           </a:p>
@@ -4491,6 +4537,30 @@
                 <a:ea typeface="Times New Roman" pitchFamily="34" charset="-122"/>
                 <a:cs typeface="Times New Roman" pitchFamily="34" charset="-120"/>
               </a:rPr>
+              <a:t>Top: aorta merged (3 labels). Bottom: aorta separate (4 labels)</a:t>
+            </a:r>
+            <a:endParaRPr lang="en-US" sz="1250" dirty="0"/>
+          </a:p>
+          <a:p>
+            <a:pPr marL="177800" indent="-177800">
+              <a:lnSpc>
+                <a:spcPct val="115000"/>
+              </a:lnSpc>
+              <a:spcAft>
+                <a:spcPts val="500"/>
+              </a:spcAft>
+              <a:buSzPct val="100000"/>
+              <a:buChar char="▪"/>
+            </a:pPr>
+            <a:r>
+              <a:rPr lang="en-US" sz="1250" dirty="0">
+                <a:solidFill>
+                  <a:srgbClr val="1F1D21"/>
+                </a:solidFill>
+                <a:latin typeface="Times New Roman" pitchFamily="34" charset="0"/>
+                <a:ea typeface="Times New Roman" pitchFamily="34" charset="-122"/>
+                <a:cs typeface="Times New Roman" pitchFamily="34" charset="-120"/>
+              </a:rPr>
               <a:t>[TODO] fragmentation risk, if any</a:t>
             </a:r>
             <a:endParaRPr lang="en-US" sz="1250" dirty="0"/>
@@ -4499,14 +4569,14 @@
       </p:sp>
       <p:sp>
         <p:nvSpPr>
-          <p:cNvPr id="11" name="Shape 9"/>
+          <p:cNvPr id="13" name="Shape 9"/>
           <p:cNvSpPr/>
           <p:nvPr/>
         </p:nvSpPr>
         <p:spPr>
           <a:xfrm>
-            <a:off x="640080" y="4417695"/>
-            <a:ext cx="4233672" cy="1005840"/>
+            <a:off x="640080" y="5349240"/>
+            <a:ext cx="10908792" cy="868680"/>
           </a:xfrm>
           <a:prstGeom prst="rect">
             <a:avLst/>
@@ -4519,14 +4589,14 @@
       </p:sp>
       <p:sp>
         <p:nvSpPr>
-          <p:cNvPr id="12" name="Shape 10"/>
+          <p:cNvPr id="14" name="Shape 10"/>
           <p:cNvSpPr/>
           <p:nvPr/>
         </p:nvSpPr>
         <p:spPr>
           <a:xfrm>
-            <a:off x="640080" y="4417695"/>
-            <a:ext cx="54864" cy="1005840"/>
+            <a:off x="640080" y="5349240"/>
+            <a:ext cx="54864" cy="868680"/>
           </a:xfrm>
           <a:prstGeom prst="rect">
             <a:avLst/>
@@ -4539,14 +4609,14 @@
       </p:sp>
       <p:sp>
         <p:nvSpPr>
-          <p:cNvPr id="13" name="Text 11"/>
-          <p:cNvSpPr txBox="1"/>
-          <p:nvPr/>
-        </p:nvSpPr>
-        <p:spPr>
-          <a:xfrm>
-            <a:off x="914400" y="4600575"/>
-            <a:ext cx="3685032" cy="274320"/>
+          <p:cNvPr id="15" name="Text 11"/>
+          <p:cNvSpPr txBox="1"/>
+          <p:nvPr/>
+        </p:nvSpPr>
+        <p:spPr>
+          <a:xfrm>
+            <a:off x="914400" y="5532120"/>
+            <a:ext cx="10360152" cy="274320"/>
           </a:xfrm>
           <a:prstGeom prst="rect">
             <a:avLst/>
@@ -4578,14 +4648,14 @@
       </p:sp>
       <p:sp>
         <p:nvSpPr>
-          <p:cNvPr id="14" name="Text 12"/>
-          <p:cNvSpPr txBox="1"/>
-          <p:nvPr/>
-        </p:nvSpPr>
-        <p:spPr>
-          <a:xfrm>
-            <a:off x="914400" y="4920615"/>
-            <a:ext cx="3685032" cy="320040"/>
+          <p:cNvPr id="16" name="Text 12"/>
+          <p:cNvSpPr txBox="1"/>
+          <p:nvPr/>
+        </p:nvSpPr>
+        <p:spPr>
+          <a:xfrm>
+            <a:off x="914400" y="5852160"/>
+            <a:ext cx="10360152" cy="182880"/>
           </a:xfrm>
           <a:prstGeom prst="rect">
             <a:avLst/>
@@ -4618,103 +4688,16 @@
           </a:p>
         </p:txBody>
       </p:sp>
-      <p:sp>
-        <p:nvSpPr>
-          <p:cNvPr id="15" name="Shape 13"/>
-          <p:cNvSpPr/>
-          <p:nvPr/>
-        </p:nvSpPr>
-        <p:spPr>
-          <a:xfrm>
-            <a:off x="5239512" y="1645920"/>
-            <a:ext cx="6309360" cy="1371600"/>
-          </a:xfrm>
-          <a:prstGeom prst="rect">
-            <a:avLst/>
-          </a:prstGeom>
-          <a:solidFill>
-            <a:srgbClr val="FFFFFF"/>
-          </a:solidFill>
-          <a:ln w="19050">
-            <a:solidFill>
-              <a:srgbClr val="D9A0AE"/>
-            </a:solidFill>
-            <a:prstDash val="dash"/>
-          </a:ln>
-        </p:spPr>
-      </p:sp>
-      <p:sp>
-        <p:nvSpPr>
-          <p:cNvPr id="16" name="Text 14"/>
-          <p:cNvSpPr txBox="1"/>
-          <p:nvPr/>
-        </p:nvSpPr>
-        <p:spPr>
-          <a:xfrm>
-            <a:off x="5239512" y="1645920"/>
-            <a:ext cx="6309360" cy="1371600"/>
-          </a:xfrm>
-          <a:prstGeom prst="rect">
-            <a:avLst/>
-          </a:prstGeom>
-          <a:noFill/>
-          <a:ln/>
-        </p:spPr>
-        <p:txBody>
-          <a:bodyPr wrap="square" lIns="0" tIns="0" rIns="0" bIns="0" rtlCol="0" anchor="ctr"/>
-          <a:lstStyle/>
-          <a:p>
-            <a:pPr algn="ctr" indent="0" marL="0">
-              <a:buNone/>
-            </a:pPr>
-            <a:r>
-              <a:rPr lang="en-US" sz="1200" i="1" dirty="0">
-                <a:solidFill>
-                  <a:srgbClr val="6B6B6B"/>
-                </a:solidFill>
-                <a:latin typeface="Times New Roman" pitchFamily="34" charset="0"/>
-                <a:ea typeface="Times New Roman" pitchFamily="34" charset="-122"/>
-                <a:cs typeface="Times New Roman" pitchFamily="34" charset="-120"/>
-              </a:rPr>
-              <a:t>Dataset make-up figure (to add)</a:t>
-            </a:r>
-            <a:endParaRPr lang="en-US" sz="1200" dirty="0"/>
-          </a:p>
-        </p:txBody>
-      </p:sp>
       <p:pic>
         <p:nvPicPr>
-          <p:cNvPr id="17" name="Image 0" descr="/Users/bellavg/ProjectsMSc/ai4mi_project/.claude/worktrees/segthor-presentation-midpoint-825c66/figures/comparison/connected_components.png">    </p:cNvPr>
+          <p:cNvPr id="17" name="Image 2" descr="/Users/bellavg/ProjectsMSc/ai4mi_project/.claude/worktrees/segthor-presentation-midpoint-825c66/deck/assets/uva_logo.png">    </p:cNvPr>
           <p:cNvPicPr>
             <a:picLocks noChangeAspect="1"/>
           </p:cNvPicPr>
           <p:nvPr/>
         </p:nvPicPr>
         <p:blipFill>
-          <a:blip r:embed="rId1"/>
-          <a:srcRect l="0" r="0" t="0" b="0"/>
-          <a:stretch/>
-        </p:blipFill>
-        <p:spPr>
-          <a:xfrm>
-            <a:off x="5239512" y="3154680"/>
-            <a:ext cx="6309360" cy="2870759"/>
-          </a:xfrm>
-          <a:prstGeom prst="rect">
-            <a:avLst/>
-          </a:prstGeom>
-        </p:spPr>
-      </p:pic>
-      <p:pic>
-        <p:nvPicPr>
-          <p:cNvPr id="18" name="Image 1" descr="/Users/bellavg/ProjectsMSc/ai4mi_project/.claude/worktrees/segthor-presentation-midpoint-825c66/deck/assets/uva_logo.png">    </p:cNvPr>
-          <p:cNvPicPr>
-            <a:picLocks noChangeAspect="1"/>
-          </p:cNvPicPr>
-          <p:nvPr/>
-        </p:nvPicPr>
-        <p:blipFill>
-          <a:blip r:embed="rId2"/>
+          <a:blip r:embed="rId3"/>
           <a:stretch>
             <a:fillRect/>
           </a:stretch>
@@ -4731,7 +4714,7 @@
       </p:pic>
       <p:sp>
         <p:nvSpPr>
-          <p:cNvPr id="19" name="Text 15"/>
+          <p:cNvPr id="18" name="Text 13"/>
           <p:cNvSpPr txBox="1"/>
           <p:nvPr/>
         </p:nvSpPr>

</xml_diff>

<commit_message>
Deck: organ position and extent figure on the spatial slide
</commit_message>
<xml_diff>
--- a/deck/midproject_outline.pptx
+++ b/deck/midproject_outline.pptx
@@ -7007,16 +7007,39 @@
           <a:ln/>
         </p:spPr>
       </p:sp>
-      <p:sp>
-        <p:nvSpPr>
-          <p:cNvPr id="7" name="Text 5"/>
-          <p:cNvSpPr txBox="1"/>
-          <p:nvPr/>
-        </p:nvSpPr>
-        <p:spPr>
-          <a:xfrm>
-            <a:off x="640080" y="1783080"/>
-            <a:ext cx="3322320" cy="274320"/>
+      <p:pic>
+        <p:nvPicPr>
+          <p:cNvPr id="7" name="Image 0" descr="/Users/bellavg/ProjectsMSc/ai4mi_project/.claude/worktrees/segthor-presentation-midpoint-825c66/figures/profile/organ_position_3d/organ_position_3d.png">    </p:cNvPr>
+          <p:cNvPicPr>
+            <a:picLocks noChangeAspect="1"/>
+          </p:cNvPicPr>
+          <p:nvPr/>
+        </p:nvPicPr>
+        <p:blipFill>
+          <a:blip r:embed="rId1"/>
+          <a:srcRect l="0" r="0" t="0" b="0"/>
+          <a:stretch/>
+        </p:blipFill>
+        <p:spPr>
+          <a:xfrm>
+            <a:off x="640080" y="1645920"/>
+            <a:ext cx="8778240" cy="2858032"/>
+          </a:xfrm>
+          <a:prstGeom prst="rect">
+            <a:avLst/>
+          </a:prstGeom>
+        </p:spPr>
+      </p:pic>
+      <p:sp>
+        <p:nvSpPr>
+          <p:cNvPr id="8" name="Text 5"/>
+          <p:cNvSpPr txBox="1"/>
+          <p:nvPr/>
+        </p:nvSpPr>
+        <p:spPr>
+          <a:xfrm>
+            <a:off x="640080" y="4641112"/>
+            <a:ext cx="2555748" cy="256032"/>
           </a:xfrm>
           <a:prstGeom prst="rect">
             <a:avLst/>
@@ -7032,7 +7055,7 @@
               <a:buNone/>
             </a:pPr>
             <a:r>
-              <a:rPr lang="en-US" sz="1200" b="1" spc="100" kern="0" dirty="0">
+              <a:rPr lang="en-US" sz="1150" b="1" spc="100" kern="0" dirty="0">
                 <a:solidFill>
                   <a:srgbClr val="E98300"/>
                 </a:solidFill>
@@ -7042,20 +7065,20 @@
               </a:rPr>
               <a:t>POSITION</a:t>
             </a:r>
-            <a:endParaRPr lang="en-US" sz="1200" dirty="0"/>
-          </a:p>
-        </p:txBody>
-      </p:sp>
-      <p:sp>
-        <p:nvSpPr>
-          <p:cNvPr id="8" name="Text 6"/>
-          <p:cNvSpPr txBox="1"/>
-          <p:nvPr/>
-        </p:nvSpPr>
-        <p:spPr>
-          <a:xfrm>
-            <a:off x="640080" y="2148840"/>
-            <a:ext cx="3322320" cy="1143000"/>
+            <a:endParaRPr lang="en-US" sz="1150" dirty="0"/>
+          </a:p>
+        </p:txBody>
+      </p:sp>
+      <p:sp>
+        <p:nvSpPr>
+          <p:cNvPr id="9" name="Text 6"/>
+          <p:cNvSpPr txBox="1"/>
+          <p:nvPr/>
+        </p:nvSpPr>
+        <p:spPr>
+          <a:xfrm>
+            <a:off x="640080" y="4933720"/>
+            <a:ext cx="2555748" cy="822960"/>
           </a:xfrm>
           <a:prstGeom prst="rect">
             <a:avLst/>
@@ -7078,7 +7101,7 @@
               <a:buChar char="▪"/>
             </a:pPr>
             <a:r>
-              <a:rPr lang="en-US" sz="1400" dirty="0">
+              <a:rPr lang="en-US" sz="1200" dirty="0">
                 <a:solidFill>
                   <a:srgbClr val="1F1D21"/>
                 </a:solidFill>
@@ -7088,7 +7111,7 @@
               </a:rPr>
               <a:t>[TODO] where each organ sits in 3D</a:t>
             </a:r>
-            <a:endParaRPr lang="en-US" sz="1400" dirty="0"/>
+            <a:endParaRPr lang="en-US" sz="1200" dirty="0"/>
           </a:p>
           <a:p>
             <a:pPr marL="177800" indent="-177800">
@@ -7102,7 +7125,7 @@
               <a:buChar char="▪"/>
             </a:pPr>
             <a:r>
-              <a:rPr lang="en-US" sz="1400" dirty="0">
+              <a:rPr lang="en-US" sz="1200" dirty="0">
                 <a:solidFill>
                   <a:srgbClr val="1F1D21"/>
                 </a:solidFill>
@@ -7112,7 +7135,7 @@
               </a:rPr>
               <a:t>[TODO]</a:t>
             </a:r>
-            <a:endParaRPr lang="en-US" sz="1400" dirty="0"/>
+            <a:endParaRPr lang="en-US" sz="1200" dirty="0"/>
           </a:p>
           <a:p>
             <a:pPr marL="177800" indent="-177800">
@@ -7126,7 +7149,7 @@
               <a:buChar char="▪"/>
             </a:pPr>
             <a:r>
-              <a:rPr lang="en-US" sz="1400" dirty="0">
+              <a:rPr lang="en-US" sz="1200" dirty="0">
                 <a:solidFill>
                   <a:srgbClr val="1F1D21"/>
                 </a:solidFill>
@@ -7136,40 +7159,20 @@
               </a:rPr>
               <a:t>[TODO]</a:t>
             </a:r>
-            <a:endParaRPr lang="en-US" sz="1400" dirty="0"/>
-          </a:p>
-        </p:txBody>
-      </p:sp>
-      <p:sp>
-        <p:nvSpPr>
-          <p:cNvPr id="9" name="Shape 7"/>
-          <p:cNvSpPr/>
-          <p:nvPr/>
-        </p:nvSpPr>
-        <p:spPr>
-          <a:xfrm>
-            <a:off x="4191000" y="1783080"/>
-            <a:ext cx="13716" cy="1508760"/>
-          </a:xfrm>
-          <a:prstGeom prst="rect">
-            <a:avLst/>
-          </a:prstGeom>
-          <a:solidFill>
-            <a:srgbClr val="E3E3E3"/>
-          </a:solidFill>
-          <a:ln/>
-        </p:spPr>
-      </p:sp>
-      <p:sp>
-        <p:nvSpPr>
-          <p:cNvPr id="10" name="Text 8"/>
-          <p:cNvSpPr txBox="1"/>
-          <p:nvPr/>
-        </p:nvSpPr>
-        <p:spPr>
-          <a:xfrm>
-            <a:off x="4419600" y="1783080"/>
-            <a:ext cx="3322320" cy="274320"/>
+            <a:endParaRPr lang="en-US" sz="1200" dirty="0"/>
+          </a:p>
+        </p:txBody>
+      </p:sp>
+      <p:sp>
+        <p:nvSpPr>
+          <p:cNvPr id="10" name="Text 7"/>
+          <p:cNvSpPr txBox="1"/>
+          <p:nvPr/>
+        </p:nvSpPr>
+        <p:spPr>
+          <a:xfrm>
+            <a:off x="3424428" y="4641112"/>
+            <a:ext cx="2555748" cy="256032"/>
           </a:xfrm>
           <a:prstGeom prst="rect">
             <a:avLst/>
@@ -7185,7 +7188,7 @@
               <a:buNone/>
             </a:pPr>
             <a:r>
-              <a:rPr lang="en-US" sz="1200" b="1" spc="100" kern="0" dirty="0">
+              <a:rPr lang="en-US" sz="1150" b="1" spc="100" kern="0" dirty="0">
                 <a:solidFill>
                   <a:srgbClr val="E98300"/>
                 </a:solidFill>
@@ -7195,20 +7198,20 @@
               </a:rPr>
               <a:t>EXTENT</a:t>
             </a:r>
-            <a:endParaRPr lang="en-US" sz="1200" dirty="0"/>
-          </a:p>
-        </p:txBody>
-      </p:sp>
-      <p:sp>
-        <p:nvSpPr>
-          <p:cNvPr id="11" name="Text 9"/>
-          <p:cNvSpPr txBox="1"/>
-          <p:nvPr/>
-        </p:nvSpPr>
-        <p:spPr>
-          <a:xfrm>
-            <a:off x="4419600" y="2148840"/>
-            <a:ext cx="3322320" cy="1143000"/>
+            <a:endParaRPr lang="en-US" sz="1150" dirty="0"/>
+          </a:p>
+        </p:txBody>
+      </p:sp>
+      <p:sp>
+        <p:nvSpPr>
+          <p:cNvPr id="11" name="Text 8"/>
+          <p:cNvSpPr txBox="1"/>
+          <p:nvPr/>
+        </p:nvSpPr>
+        <p:spPr>
+          <a:xfrm>
+            <a:off x="3424428" y="4933720"/>
+            <a:ext cx="2555748" cy="1014984"/>
           </a:xfrm>
           <a:prstGeom prst="rect">
             <a:avLst/>
@@ -7231,7 +7234,7 @@
               <a:buChar char="▪"/>
             </a:pPr>
             <a:r>
-              <a:rPr lang="en-US" sz="1400" dirty="0">
+              <a:rPr lang="en-US" sz="1200" dirty="0">
                 <a:solidFill>
                   <a:srgbClr val="1F1D21"/>
                 </a:solidFill>
@@ -7241,7 +7244,7 @@
               </a:rPr>
               <a:t>[TODO] coverage along the body axis</a:t>
             </a:r>
-            <a:endParaRPr lang="en-US" sz="1400" dirty="0"/>
+            <a:endParaRPr lang="en-US" sz="1200" dirty="0"/>
           </a:p>
           <a:p>
             <a:pPr marL="177800" indent="-177800">
@@ -7255,7 +7258,7 @@
               <a:buChar char="▪"/>
             </a:pPr>
             <a:r>
-              <a:rPr lang="en-US" sz="1400" dirty="0">
+              <a:rPr lang="en-US" sz="1200" dirty="0">
                 <a:solidFill>
                   <a:srgbClr val="1F1D21"/>
                 </a:solidFill>
@@ -7265,7 +7268,7 @@
               </a:rPr>
               <a:t>[TODO]</a:t>
             </a:r>
-            <a:endParaRPr lang="en-US" sz="1400" dirty="0"/>
+            <a:endParaRPr lang="en-US" sz="1200" dirty="0"/>
           </a:p>
           <a:p>
             <a:pPr marL="177800" indent="-177800">
@@ -7279,7 +7282,7 @@
               <a:buChar char="▪"/>
             </a:pPr>
             <a:r>
-              <a:rPr lang="en-US" sz="1400" dirty="0">
+              <a:rPr lang="en-US" sz="1200" dirty="0">
                 <a:solidFill>
                   <a:srgbClr val="1F1D21"/>
                 </a:solidFill>
@@ -7289,40 +7292,20 @@
               </a:rPr>
               <a:t>[TODO]</a:t>
             </a:r>
-            <a:endParaRPr lang="en-US" sz="1400" dirty="0"/>
-          </a:p>
-        </p:txBody>
-      </p:sp>
-      <p:sp>
-        <p:nvSpPr>
-          <p:cNvPr id="12" name="Shape 10"/>
-          <p:cNvSpPr/>
-          <p:nvPr/>
-        </p:nvSpPr>
-        <p:spPr>
-          <a:xfrm>
-            <a:off x="7970520" y="1783080"/>
-            <a:ext cx="13716" cy="1508760"/>
-          </a:xfrm>
-          <a:prstGeom prst="rect">
-            <a:avLst/>
-          </a:prstGeom>
-          <a:solidFill>
-            <a:srgbClr val="E3E3E3"/>
-          </a:solidFill>
-          <a:ln/>
-        </p:spPr>
-      </p:sp>
-      <p:sp>
-        <p:nvSpPr>
-          <p:cNvPr id="13" name="Text 11"/>
-          <p:cNvSpPr txBox="1"/>
-          <p:nvPr/>
-        </p:nvSpPr>
-        <p:spPr>
-          <a:xfrm>
-            <a:off x="8199120" y="1783080"/>
-            <a:ext cx="3322320" cy="274320"/>
+            <a:endParaRPr lang="en-US" sz="1200" dirty="0"/>
+          </a:p>
+        </p:txBody>
+      </p:sp>
+      <p:sp>
+        <p:nvSpPr>
+          <p:cNvPr id="12" name="Text 9"/>
+          <p:cNvSpPr txBox="1"/>
+          <p:nvPr/>
+        </p:nvSpPr>
+        <p:spPr>
+          <a:xfrm>
+            <a:off x="6208776" y="4641112"/>
+            <a:ext cx="2555748" cy="256032"/>
           </a:xfrm>
           <a:prstGeom prst="rect">
             <a:avLst/>
@@ -7338,7 +7321,7 @@
               <a:buNone/>
             </a:pPr>
             <a:r>
-              <a:rPr lang="en-US" sz="1200" b="1" spc="100" kern="0" dirty="0">
+              <a:rPr lang="en-US" sz="1150" b="1" spc="100" kern="0" dirty="0">
                 <a:solidFill>
                   <a:srgbClr val="E98300"/>
                 </a:solidFill>
@@ -7348,20 +7331,20 @@
               </a:rPr>
               <a:t>ADJACENCY</a:t>
             </a:r>
-            <a:endParaRPr lang="en-US" sz="1200" dirty="0"/>
-          </a:p>
-        </p:txBody>
-      </p:sp>
-      <p:sp>
-        <p:nvSpPr>
-          <p:cNvPr id="14" name="Text 12"/>
-          <p:cNvSpPr txBox="1"/>
-          <p:nvPr/>
-        </p:nvSpPr>
-        <p:spPr>
-          <a:xfrm>
-            <a:off x="8199120" y="2148840"/>
-            <a:ext cx="3322320" cy="1143000"/>
+            <a:endParaRPr lang="en-US" sz="1150" dirty="0"/>
+          </a:p>
+        </p:txBody>
+      </p:sp>
+      <p:sp>
+        <p:nvSpPr>
+          <p:cNvPr id="13" name="Text 10"/>
+          <p:cNvSpPr txBox="1"/>
+          <p:nvPr/>
+        </p:nvSpPr>
+        <p:spPr>
+          <a:xfrm>
+            <a:off x="6208776" y="4933720"/>
+            <a:ext cx="2555748" cy="1014984"/>
           </a:xfrm>
           <a:prstGeom prst="rect">
             <a:avLst/>
@@ -7384,7 +7367,7 @@
               <a:buChar char="▪"/>
             </a:pPr>
             <a:r>
-              <a:rPr lang="en-US" sz="1400" dirty="0">
+              <a:rPr lang="en-US" sz="1200" dirty="0">
                 <a:solidFill>
                   <a:srgbClr val="1F1D21"/>
                 </a:solidFill>
@@ -7394,7 +7377,7 @@
               </a:rPr>
               <a:t>[TODO] contact between label pairs</a:t>
             </a:r>
-            <a:endParaRPr lang="en-US" sz="1400" dirty="0"/>
+            <a:endParaRPr lang="en-US" sz="1200" dirty="0"/>
           </a:p>
           <a:p>
             <a:pPr marL="177800" indent="-177800">
@@ -7408,7 +7391,7 @@
               <a:buChar char="▪"/>
             </a:pPr>
             <a:r>
-              <a:rPr lang="en-US" sz="1400" dirty="0">
+              <a:rPr lang="en-US" sz="1200" dirty="0">
                 <a:solidFill>
                   <a:srgbClr val="1F1D21"/>
                 </a:solidFill>
@@ -7418,7 +7401,7 @@
               </a:rPr>
               <a:t>[TODO] which pairs matter most, now that aorta is real</a:t>
             </a:r>
-            <a:endParaRPr lang="en-US" sz="1400" dirty="0"/>
+            <a:endParaRPr lang="en-US" sz="1200" dirty="0"/>
           </a:p>
           <a:p>
             <a:pPr marL="177800" indent="-177800">
@@ -7432,7 +7415,7 @@
               <a:buChar char="▪"/>
             </a:pPr>
             <a:r>
-              <a:rPr lang="en-US" sz="1400" dirty="0">
+              <a:rPr lang="en-US" sz="1200" dirty="0">
                 <a:solidFill>
                   <a:srgbClr val="1F1D21"/>
                 </a:solidFill>
@@ -7442,20 +7425,20 @@
               </a:rPr>
               <a:t>[TODO]</a:t>
             </a:r>
-            <a:endParaRPr lang="en-US" sz="1400" dirty="0"/>
-          </a:p>
-        </p:txBody>
-      </p:sp>
-      <p:sp>
-        <p:nvSpPr>
-          <p:cNvPr id="15" name="Shape 13"/>
+            <a:endParaRPr lang="en-US" sz="1200" dirty="0"/>
+          </a:p>
+        </p:txBody>
+      </p:sp>
+      <p:sp>
+        <p:nvSpPr>
+          <p:cNvPr id="14" name="Shape 11"/>
           <p:cNvSpPr/>
           <p:nvPr/>
         </p:nvSpPr>
         <p:spPr>
           <a:xfrm>
-            <a:off x="640080" y="3611880"/>
-            <a:ext cx="10881360" cy="914400"/>
+            <a:off x="8993124" y="4641112"/>
+            <a:ext cx="2555748" cy="1554480"/>
           </a:xfrm>
           <a:prstGeom prst="rect">
             <a:avLst/>
@@ -7468,14 +7451,14 @@
       </p:sp>
       <p:sp>
         <p:nvSpPr>
-          <p:cNvPr id="16" name="Shape 14"/>
+          <p:cNvPr id="15" name="Shape 12"/>
           <p:cNvSpPr/>
           <p:nvPr/>
         </p:nvSpPr>
         <p:spPr>
           <a:xfrm>
-            <a:off x="640080" y="3611880"/>
-            <a:ext cx="54864" cy="914400"/>
+            <a:off x="8993124" y="4641112"/>
+            <a:ext cx="54864" cy="1554480"/>
           </a:xfrm>
           <a:prstGeom prst="rect">
             <a:avLst/>
@@ -7488,14 +7471,14 @@
       </p:sp>
       <p:sp>
         <p:nvSpPr>
-          <p:cNvPr id="17" name="Text 15"/>
-          <p:cNvSpPr txBox="1"/>
-          <p:nvPr/>
-        </p:nvSpPr>
-        <p:spPr>
-          <a:xfrm>
-            <a:off x="914400" y="3794760"/>
-            <a:ext cx="10332720" cy="274320"/>
+          <p:cNvPr id="16" name="Text 13"/>
+          <p:cNvSpPr txBox="1"/>
+          <p:nvPr/>
+        </p:nvSpPr>
+        <p:spPr>
+          <a:xfrm>
+            <a:off x="9267444" y="4823992"/>
+            <a:ext cx="2007108" cy="274320"/>
           </a:xfrm>
           <a:prstGeom prst="rect">
             <a:avLst/>
@@ -7527,14 +7510,14 @@
       </p:sp>
       <p:sp>
         <p:nvSpPr>
-          <p:cNvPr id="18" name="Text 16"/>
-          <p:cNvSpPr txBox="1"/>
-          <p:nvPr/>
-        </p:nvSpPr>
-        <p:spPr>
-          <a:xfrm>
-            <a:off x="914400" y="4114800"/>
-            <a:ext cx="10332720" cy="228600"/>
+          <p:cNvPr id="17" name="Text 14"/>
+          <p:cNvSpPr txBox="1"/>
+          <p:nvPr/>
+        </p:nvSpPr>
+        <p:spPr>
+          <a:xfrm>
+            <a:off x="9267444" y="5144032"/>
+            <a:ext cx="2007108" cy="868680"/>
           </a:xfrm>
           <a:prstGeom prst="rect">
             <a:avLst/>
@@ -7569,14 +7552,14 @@
       </p:sp>
       <p:pic>
         <p:nvPicPr>
-          <p:cNvPr id="19" name="Image 0" descr="/Users/bellavg/ProjectsMSc/ai4mi_project/.claude/worktrees/segthor-presentation-midpoint-825c66/deck/assets/uva_logo.png">    </p:cNvPr>
+          <p:cNvPr id="18" name="Image 1" descr="/Users/bellavg/ProjectsMSc/ai4mi_project/.claude/worktrees/segthor-presentation-midpoint-825c66/deck/assets/uva_logo.png">    </p:cNvPr>
           <p:cNvPicPr>
             <a:picLocks noChangeAspect="1"/>
           </p:cNvPicPr>
           <p:nvPr/>
         </p:nvPicPr>
         <p:blipFill>
-          <a:blip r:embed="rId1"/>
+          <a:blip r:embed="rId2"/>
           <a:stretch>
             <a:fillRect/>
           </a:stretch>
@@ -7593,7 +7576,7 @@
       </p:pic>
       <p:sp>
         <p:nvSpPr>
-          <p:cNvPr id="20" name="Text 17"/>
+          <p:cNvPr id="19" name="Text 15"/>
           <p:cNvSpPr txBox="1"/>
           <p:nvPr/>
         </p:nvSpPr>

</xml_diff>

<commit_message>
Deck: spatial slide with lean contact strip and skinnier text block
</commit_message>
<xml_diff>
--- a/deck/midproject_outline.pptx
+++ b/deck/midproject_outline.pptx
@@ -7022,8 +7022,8 @@
         </p:blipFill>
         <p:spPr>
           <a:xfrm>
-            <a:off x="640080" y="1645920"/>
-            <a:ext cx="8778240" cy="2858032"/>
+            <a:off x="699371" y="1631950"/>
+            <a:ext cx="8815614" cy="2870200"/>
           </a:xfrm>
           <a:prstGeom prst="rect">
             <a:avLst/>
@@ -7032,14 +7032,54 @@
       </p:pic>
       <p:sp>
         <p:nvSpPr>
-          <p:cNvPr id="8" name="Text 5"/>
-          <p:cNvSpPr txBox="1"/>
-          <p:nvPr/>
-        </p:nvSpPr>
-        <p:spPr>
-          <a:xfrm>
-            <a:off x="640080" y="4641112"/>
-            <a:ext cx="2555748" cy="256032"/>
+          <p:cNvPr id="8" name="Shape 5"/>
+          <p:cNvSpPr/>
+          <p:nvPr/>
+        </p:nvSpPr>
+        <p:spPr>
+          <a:xfrm>
+            <a:off x="9804908" y="1835150"/>
+            <a:ext cx="1574356" cy="2518791"/>
+          </a:xfrm>
+          <a:prstGeom prst="rect">
+            <a:avLst/>
+          </a:prstGeom>
+          <a:solidFill>
+            <a:srgbClr val="FCEEDC"/>
+          </a:solidFill>
+          <a:ln/>
+        </p:spPr>
+      </p:sp>
+      <p:sp>
+        <p:nvSpPr>
+          <p:cNvPr id="9" name="Shape 6"/>
+          <p:cNvSpPr/>
+          <p:nvPr/>
+        </p:nvSpPr>
+        <p:spPr>
+          <a:xfrm>
+            <a:off x="9804908" y="1835150"/>
+            <a:ext cx="54864" cy="2518791"/>
+          </a:xfrm>
+          <a:prstGeom prst="rect">
+            <a:avLst/>
+          </a:prstGeom>
+          <a:solidFill>
+            <a:srgbClr val="E98300"/>
+          </a:solidFill>
+          <a:ln/>
+        </p:spPr>
+      </p:sp>
+      <p:sp>
+        <p:nvSpPr>
+          <p:cNvPr id="10" name="Text 7"/>
+          <p:cNvSpPr txBox="1"/>
+          <p:nvPr/>
+        </p:nvSpPr>
+        <p:spPr>
+          <a:xfrm>
+            <a:off x="10079228" y="2018030"/>
+            <a:ext cx="1025716" cy="274320"/>
           </a:xfrm>
           <a:prstGeom prst="rect">
             <a:avLst/>
@@ -7055,6 +7095,87 @@
               <a:buNone/>
             </a:pPr>
             <a:r>
+              <a:rPr lang="en-US" sz="1100" b="1" spc="100" kern="0" dirty="0">
+                <a:solidFill>
+                  <a:srgbClr val="E98300"/>
+                </a:solidFill>
+                <a:latin typeface="Times New Roman" pitchFamily="34" charset="0"/>
+                <a:ea typeface="Times New Roman" pitchFamily="34" charset="-122"/>
+                <a:cs typeface="Times New Roman" pitchFamily="34" charset="-120"/>
+              </a:rPr>
+              <a:t>WHY THIS MATTERS</a:t>
+            </a:r>
+            <a:endParaRPr lang="en-US" sz="1100" dirty="0"/>
+          </a:p>
+        </p:txBody>
+      </p:sp>
+      <p:sp>
+        <p:nvSpPr>
+          <p:cNvPr id="11" name="Text 8"/>
+          <p:cNvSpPr txBox="1"/>
+          <p:nvPr/>
+        </p:nvSpPr>
+        <p:spPr>
+          <a:xfrm>
+            <a:off x="10079228" y="2338070"/>
+            <a:ext cx="1025716" cy="1832991"/>
+          </a:xfrm>
+          <a:prstGeom prst="rect">
+            <a:avLst/>
+          </a:prstGeom>
+          <a:noFill/>
+          <a:ln/>
+        </p:spPr>
+        <p:txBody>
+          <a:bodyPr wrap="square" lIns="0" tIns="0" rIns="0" bIns="0" rtlCol="0" anchor="t"/>
+          <a:lstStyle/>
+          <a:p>
+            <a:pPr indent="0" marL="0">
+              <a:lnSpc>
+                <a:spcPct val="118000"/>
+              </a:lnSpc>
+              <a:buNone/>
+            </a:pPr>
+            <a:r>
+              <a:rPr lang="en-US" sz="1350" dirty="0">
+                <a:solidFill>
+                  <a:srgbClr val="1F1D21"/>
+                </a:solidFill>
+                <a:latin typeface="Times New Roman" pitchFamily="34" charset="0"/>
+                <a:ea typeface="Times New Roman" pitchFamily="34" charset="-122"/>
+                <a:cs typeface="Times New Roman" pitchFamily="34" charset="-120"/>
+              </a:rPr>
+              <a:t>[TODO] how position and extent inform the preprocessing decisions on the next slide.</a:t>
+            </a:r>
+            <a:endParaRPr lang="en-US" sz="1350" dirty="0"/>
+          </a:p>
+        </p:txBody>
+      </p:sp>
+      <p:sp>
+        <p:nvSpPr>
+          <p:cNvPr id="12" name="Text 9"/>
+          <p:cNvSpPr txBox="1"/>
+          <p:nvPr/>
+        </p:nvSpPr>
+        <p:spPr>
+          <a:xfrm>
+            <a:off x="1142810" y="4746689"/>
+            <a:ext cx="3610229" cy="256032"/>
+          </a:xfrm>
+          <a:prstGeom prst="rect">
+            <a:avLst/>
+          </a:prstGeom>
+          <a:noFill/>
+          <a:ln/>
+        </p:spPr>
+        <p:txBody>
+          <a:bodyPr wrap="square" lIns="0" tIns="0" rIns="0" bIns="0" rtlCol="0" anchor="ctr"/>
+          <a:lstStyle/>
+          <a:p>
+            <a:pPr indent="0" marL="0">
+              <a:buNone/>
+            </a:pPr>
+            <a:r>
               <a:rPr lang="en-US" sz="1150" b="1" spc="100" kern="0" dirty="0">
                 <a:solidFill>
                   <a:srgbClr val="E98300"/>
@@ -7063,7 +7184,7 @@
                 <a:ea typeface="Times New Roman" pitchFamily="34" charset="-122"/>
                 <a:cs typeface="Times New Roman" pitchFamily="34" charset="-120"/>
               </a:rPr>
-              <a:t>POSITION</a:t>
+              <a:t>POSITION, EXTENT &amp; ADJACENCY</a:t>
             </a:r>
             <a:endParaRPr lang="en-US" sz="1150" dirty="0"/>
           </a:p>
@@ -7071,14 +7192,14 @@
       </p:sp>
       <p:sp>
         <p:nvSpPr>
-          <p:cNvPr id="9" name="Text 6"/>
-          <p:cNvSpPr txBox="1"/>
-          <p:nvPr/>
-        </p:nvSpPr>
-        <p:spPr>
-          <a:xfrm>
-            <a:off x="640080" y="4933720"/>
-            <a:ext cx="2555748" cy="822960"/>
+          <p:cNvPr id="13" name="Text 10"/>
+          <p:cNvSpPr txBox="1"/>
+          <p:nvPr/>
+        </p:nvSpPr>
+        <p:spPr>
+          <a:xfrm>
+            <a:off x="1142810" y="5039297"/>
+            <a:ext cx="3610229" cy="1014984"/>
           </a:xfrm>
           <a:prstGeom prst="rect">
             <a:avLst/>
@@ -7133,7 +7254,7 @@
                 <a:ea typeface="Times New Roman" pitchFamily="34" charset="-122"/>
                 <a:cs typeface="Times New Roman" pitchFamily="34" charset="-120"/>
               </a:rPr>
-              <a:t>[TODO]</a:t>
+              <a:t>[TODO] coverage along the body axis</a:t>
             </a:r>
             <a:endParaRPr lang="en-US" sz="1200" dirty="0"/>
           </a:p>
@@ -7157,402 +7278,15 @@
                 <a:ea typeface="Times New Roman" pitchFamily="34" charset="-122"/>
                 <a:cs typeface="Times New Roman" pitchFamily="34" charset="-120"/>
               </a:rPr>
-              <a:t>[TODO]</a:t>
+              <a:t>[TODO] which pairs matter most, now that aorta is real</a:t>
             </a:r>
             <a:endParaRPr lang="en-US" sz="1200" dirty="0"/>
-          </a:p>
-        </p:txBody>
-      </p:sp>
-      <p:sp>
-        <p:nvSpPr>
-          <p:cNvPr id="10" name="Text 7"/>
-          <p:cNvSpPr txBox="1"/>
-          <p:nvPr/>
-        </p:nvSpPr>
-        <p:spPr>
-          <a:xfrm>
-            <a:off x="3424428" y="4641112"/>
-            <a:ext cx="2555748" cy="256032"/>
-          </a:xfrm>
-          <a:prstGeom prst="rect">
-            <a:avLst/>
-          </a:prstGeom>
-          <a:noFill/>
-          <a:ln/>
-        </p:spPr>
-        <p:txBody>
-          <a:bodyPr wrap="square" lIns="0" tIns="0" rIns="0" bIns="0" rtlCol="0" anchor="ctr"/>
-          <a:lstStyle/>
-          <a:p>
-            <a:pPr indent="0" marL="0">
-              <a:buNone/>
-            </a:pPr>
-            <a:r>
-              <a:rPr lang="en-US" sz="1150" b="1" spc="100" kern="0" dirty="0">
-                <a:solidFill>
-                  <a:srgbClr val="E98300"/>
-                </a:solidFill>
-                <a:latin typeface="Times New Roman" pitchFamily="34" charset="0"/>
-                <a:ea typeface="Times New Roman" pitchFamily="34" charset="-122"/>
-                <a:cs typeface="Times New Roman" pitchFamily="34" charset="-120"/>
-              </a:rPr>
-              <a:t>EXTENT</a:t>
-            </a:r>
-            <a:endParaRPr lang="en-US" sz="1150" dirty="0"/>
-          </a:p>
-        </p:txBody>
-      </p:sp>
-      <p:sp>
-        <p:nvSpPr>
-          <p:cNvPr id="11" name="Text 8"/>
-          <p:cNvSpPr txBox="1"/>
-          <p:nvPr/>
-        </p:nvSpPr>
-        <p:spPr>
-          <a:xfrm>
-            <a:off x="3424428" y="4933720"/>
-            <a:ext cx="2555748" cy="1014984"/>
-          </a:xfrm>
-          <a:prstGeom prst="rect">
-            <a:avLst/>
-          </a:prstGeom>
-          <a:noFill/>
-          <a:ln/>
-        </p:spPr>
-        <p:txBody>
-          <a:bodyPr wrap="square" lIns="0" tIns="0" rIns="0" bIns="0" rtlCol="0" anchor="t"/>
-          <a:lstStyle/>
-          <a:p>
-            <a:pPr marL="177800" indent="-177800">
-              <a:lnSpc>
-                <a:spcPct val="115000"/>
-              </a:lnSpc>
-              <a:spcAft>
-                <a:spcPts val="500"/>
-              </a:spcAft>
-              <a:buSzPct val="100000"/>
-              <a:buChar char="▪"/>
-            </a:pPr>
-            <a:r>
-              <a:rPr lang="en-US" sz="1200" dirty="0">
-                <a:solidFill>
-                  <a:srgbClr val="1F1D21"/>
-                </a:solidFill>
-                <a:latin typeface="Times New Roman" pitchFamily="34" charset="0"/>
-                <a:ea typeface="Times New Roman" pitchFamily="34" charset="-122"/>
-                <a:cs typeface="Times New Roman" pitchFamily="34" charset="-120"/>
-              </a:rPr>
-              <a:t>[TODO] coverage along the body axis</a:t>
-            </a:r>
-            <a:endParaRPr lang="en-US" sz="1200" dirty="0"/>
-          </a:p>
-          <a:p>
-            <a:pPr marL="177800" indent="-177800">
-              <a:lnSpc>
-                <a:spcPct val="115000"/>
-              </a:lnSpc>
-              <a:spcAft>
-                <a:spcPts val="500"/>
-              </a:spcAft>
-              <a:buSzPct val="100000"/>
-              <a:buChar char="▪"/>
-            </a:pPr>
-            <a:r>
-              <a:rPr lang="en-US" sz="1200" dirty="0">
-                <a:solidFill>
-                  <a:srgbClr val="1F1D21"/>
-                </a:solidFill>
-                <a:latin typeface="Times New Roman" pitchFamily="34" charset="0"/>
-                <a:ea typeface="Times New Roman" pitchFamily="34" charset="-122"/>
-                <a:cs typeface="Times New Roman" pitchFamily="34" charset="-120"/>
-              </a:rPr>
-              <a:t>[TODO]</a:t>
-            </a:r>
-            <a:endParaRPr lang="en-US" sz="1200" dirty="0"/>
-          </a:p>
-          <a:p>
-            <a:pPr marL="177800" indent="-177800">
-              <a:lnSpc>
-                <a:spcPct val="115000"/>
-              </a:lnSpc>
-              <a:spcAft>
-                <a:spcPts val="500"/>
-              </a:spcAft>
-              <a:buSzPct val="100000"/>
-              <a:buChar char="▪"/>
-            </a:pPr>
-            <a:r>
-              <a:rPr lang="en-US" sz="1200" dirty="0">
-                <a:solidFill>
-                  <a:srgbClr val="1F1D21"/>
-                </a:solidFill>
-                <a:latin typeface="Times New Roman" pitchFamily="34" charset="0"/>
-                <a:ea typeface="Times New Roman" pitchFamily="34" charset="-122"/>
-                <a:cs typeface="Times New Roman" pitchFamily="34" charset="-120"/>
-              </a:rPr>
-              <a:t>[TODO]</a:t>
-            </a:r>
-            <a:endParaRPr lang="en-US" sz="1200" dirty="0"/>
-          </a:p>
-        </p:txBody>
-      </p:sp>
-      <p:sp>
-        <p:nvSpPr>
-          <p:cNvPr id="12" name="Text 9"/>
-          <p:cNvSpPr txBox="1"/>
-          <p:nvPr/>
-        </p:nvSpPr>
-        <p:spPr>
-          <a:xfrm>
-            <a:off x="6208776" y="4641112"/>
-            <a:ext cx="2555748" cy="256032"/>
-          </a:xfrm>
-          <a:prstGeom prst="rect">
-            <a:avLst/>
-          </a:prstGeom>
-          <a:noFill/>
-          <a:ln/>
-        </p:spPr>
-        <p:txBody>
-          <a:bodyPr wrap="square" lIns="0" tIns="0" rIns="0" bIns="0" rtlCol="0" anchor="ctr"/>
-          <a:lstStyle/>
-          <a:p>
-            <a:pPr indent="0" marL="0">
-              <a:buNone/>
-            </a:pPr>
-            <a:r>
-              <a:rPr lang="en-US" sz="1150" b="1" spc="100" kern="0" dirty="0">
-                <a:solidFill>
-                  <a:srgbClr val="E98300"/>
-                </a:solidFill>
-                <a:latin typeface="Times New Roman" pitchFamily="34" charset="0"/>
-                <a:ea typeface="Times New Roman" pitchFamily="34" charset="-122"/>
-                <a:cs typeface="Times New Roman" pitchFamily="34" charset="-120"/>
-              </a:rPr>
-              <a:t>ADJACENCY</a:t>
-            </a:r>
-            <a:endParaRPr lang="en-US" sz="1150" dirty="0"/>
-          </a:p>
-        </p:txBody>
-      </p:sp>
-      <p:sp>
-        <p:nvSpPr>
-          <p:cNvPr id="13" name="Text 10"/>
-          <p:cNvSpPr txBox="1"/>
-          <p:nvPr/>
-        </p:nvSpPr>
-        <p:spPr>
-          <a:xfrm>
-            <a:off x="6208776" y="4933720"/>
-            <a:ext cx="2555748" cy="1014984"/>
-          </a:xfrm>
-          <a:prstGeom prst="rect">
-            <a:avLst/>
-          </a:prstGeom>
-          <a:noFill/>
-          <a:ln/>
-        </p:spPr>
-        <p:txBody>
-          <a:bodyPr wrap="square" lIns="0" tIns="0" rIns="0" bIns="0" rtlCol="0" anchor="t"/>
-          <a:lstStyle/>
-          <a:p>
-            <a:pPr marL="177800" indent="-177800">
-              <a:lnSpc>
-                <a:spcPct val="115000"/>
-              </a:lnSpc>
-              <a:spcAft>
-                <a:spcPts val="500"/>
-              </a:spcAft>
-              <a:buSzPct val="100000"/>
-              <a:buChar char="▪"/>
-            </a:pPr>
-            <a:r>
-              <a:rPr lang="en-US" sz="1200" dirty="0">
-                <a:solidFill>
-                  <a:srgbClr val="1F1D21"/>
-                </a:solidFill>
-                <a:latin typeface="Times New Roman" pitchFamily="34" charset="0"/>
-                <a:ea typeface="Times New Roman" pitchFamily="34" charset="-122"/>
-                <a:cs typeface="Times New Roman" pitchFamily="34" charset="-120"/>
-              </a:rPr>
-              <a:t>[TODO] contact between label pairs</a:t>
-            </a:r>
-            <a:endParaRPr lang="en-US" sz="1200" dirty="0"/>
-          </a:p>
-          <a:p>
-            <a:pPr marL="177800" indent="-177800">
-              <a:lnSpc>
-                <a:spcPct val="115000"/>
-              </a:lnSpc>
-              <a:spcAft>
-                <a:spcPts val="500"/>
-              </a:spcAft>
-              <a:buSzPct val="100000"/>
-              <a:buChar char="▪"/>
-            </a:pPr>
-            <a:r>
-              <a:rPr lang="en-US" sz="1200" dirty="0">
-                <a:solidFill>
-                  <a:srgbClr val="1F1D21"/>
-                </a:solidFill>
-                <a:latin typeface="Times New Roman" pitchFamily="34" charset="0"/>
-                <a:ea typeface="Times New Roman" pitchFamily="34" charset="-122"/>
-                <a:cs typeface="Times New Roman" pitchFamily="34" charset="-120"/>
-              </a:rPr>
-              <a:t>[TODO] which pairs matter most, now that aorta is real</a:t>
-            </a:r>
-            <a:endParaRPr lang="en-US" sz="1200" dirty="0"/>
-          </a:p>
-          <a:p>
-            <a:pPr marL="177800" indent="-177800">
-              <a:lnSpc>
-                <a:spcPct val="115000"/>
-              </a:lnSpc>
-              <a:spcAft>
-                <a:spcPts val="500"/>
-              </a:spcAft>
-              <a:buSzPct val="100000"/>
-              <a:buChar char="▪"/>
-            </a:pPr>
-            <a:r>
-              <a:rPr lang="en-US" sz="1200" dirty="0">
-                <a:solidFill>
-                  <a:srgbClr val="1F1D21"/>
-                </a:solidFill>
-                <a:latin typeface="Times New Roman" pitchFamily="34" charset="0"/>
-                <a:ea typeface="Times New Roman" pitchFamily="34" charset="-122"/>
-                <a:cs typeface="Times New Roman" pitchFamily="34" charset="-120"/>
-              </a:rPr>
-              <a:t>[TODO]</a:t>
-            </a:r>
-            <a:endParaRPr lang="en-US" sz="1200" dirty="0"/>
-          </a:p>
-        </p:txBody>
-      </p:sp>
-      <p:sp>
-        <p:nvSpPr>
-          <p:cNvPr id="14" name="Shape 11"/>
-          <p:cNvSpPr/>
-          <p:nvPr/>
-        </p:nvSpPr>
-        <p:spPr>
-          <a:xfrm>
-            <a:off x="8993124" y="4641112"/>
-            <a:ext cx="2555748" cy="1554480"/>
-          </a:xfrm>
-          <a:prstGeom prst="rect">
-            <a:avLst/>
-          </a:prstGeom>
-          <a:solidFill>
-            <a:srgbClr val="FCEEDC"/>
-          </a:solidFill>
-          <a:ln/>
-        </p:spPr>
-      </p:sp>
-      <p:sp>
-        <p:nvSpPr>
-          <p:cNvPr id="15" name="Shape 12"/>
-          <p:cNvSpPr/>
-          <p:nvPr/>
-        </p:nvSpPr>
-        <p:spPr>
-          <a:xfrm>
-            <a:off x="8993124" y="4641112"/>
-            <a:ext cx="54864" cy="1554480"/>
-          </a:xfrm>
-          <a:prstGeom prst="rect">
-            <a:avLst/>
-          </a:prstGeom>
-          <a:solidFill>
-            <a:srgbClr val="E98300"/>
-          </a:solidFill>
-          <a:ln/>
-        </p:spPr>
-      </p:sp>
-      <p:sp>
-        <p:nvSpPr>
-          <p:cNvPr id="16" name="Text 13"/>
-          <p:cNvSpPr txBox="1"/>
-          <p:nvPr/>
-        </p:nvSpPr>
-        <p:spPr>
-          <a:xfrm>
-            <a:off x="9267444" y="4823992"/>
-            <a:ext cx="2007108" cy="274320"/>
-          </a:xfrm>
-          <a:prstGeom prst="rect">
-            <a:avLst/>
-          </a:prstGeom>
-          <a:noFill/>
-          <a:ln/>
-        </p:spPr>
-        <p:txBody>
-          <a:bodyPr wrap="square" lIns="0" tIns="0" rIns="0" bIns="0" rtlCol="0" anchor="ctr"/>
-          <a:lstStyle/>
-          <a:p>
-            <a:pPr indent="0" marL="0">
-              <a:buNone/>
-            </a:pPr>
-            <a:r>
-              <a:rPr lang="en-US" sz="1100" b="1" spc="100" kern="0" dirty="0">
-                <a:solidFill>
-                  <a:srgbClr val="E98300"/>
-                </a:solidFill>
-                <a:latin typeface="Times New Roman" pitchFamily="34" charset="0"/>
-                <a:ea typeface="Times New Roman" pitchFamily="34" charset="-122"/>
-                <a:cs typeface="Times New Roman" pitchFamily="34" charset="-120"/>
-              </a:rPr>
-              <a:t>WHY THIS MATTERS</a:t>
-            </a:r>
-            <a:endParaRPr lang="en-US" sz="1100" dirty="0"/>
-          </a:p>
-        </p:txBody>
-      </p:sp>
-      <p:sp>
-        <p:nvSpPr>
-          <p:cNvPr id="17" name="Text 14"/>
-          <p:cNvSpPr txBox="1"/>
-          <p:nvPr/>
-        </p:nvSpPr>
-        <p:spPr>
-          <a:xfrm>
-            <a:off x="9267444" y="5144032"/>
-            <a:ext cx="2007108" cy="868680"/>
-          </a:xfrm>
-          <a:prstGeom prst="rect">
-            <a:avLst/>
-          </a:prstGeom>
-          <a:noFill/>
-          <a:ln/>
-        </p:spPr>
-        <p:txBody>
-          <a:bodyPr wrap="square" lIns="0" tIns="0" rIns="0" bIns="0" rtlCol="0" anchor="t"/>
-          <a:lstStyle/>
-          <a:p>
-            <a:pPr indent="0" marL="0">
-              <a:lnSpc>
-                <a:spcPct val="118000"/>
-              </a:lnSpc>
-              <a:buNone/>
-            </a:pPr>
-            <a:r>
-              <a:rPr lang="en-US" sz="1350" dirty="0">
-                <a:solidFill>
-                  <a:srgbClr val="1F1D21"/>
-                </a:solidFill>
-                <a:latin typeface="Times New Roman" pitchFamily="34" charset="0"/>
-                <a:ea typeface="Times New Roman" pitchFamily="34" charset="-122"/>
-                <a:cs typeface="Times New Roman" pitchFamily="34" charset="-120"/>
-              </a:rPr>
-              <a:t>[TODO] how position and extent inform the preprocessing decisions on the next slide.</a:t>
-            </a:r>
-            <a:endParaRPr lang="en-US" sz="1350" dirty="0"/>
           </a:p>
         </p:txBody>
       </p:sp>
       <p:pic>
         <p:nvPicPr>
-          <p:cNvPr id="18" name="Image 1" descr="/Users/bellavg/ProjectsMSc/ai4mi_project/.claude/worktrees/segthor-presentation-midpoint-825c66/deck/assets/uva_logo.png">    </p:cNvPr>
+          <p:cNvPr id="14" name="Image 1" descr="/Users/bellavg/ProjectsMSc/ai4mi_project/.claude/worktrees/segthor-presentation-midpoint-825c66/figures/profile/label_pairs/label_pairs_strip.png">    </p:cNvPr>
           <p:cNvPicPr>
             <a:picLocks noChangeAspect="1"/>
           </p:cNvPicPr>
@@ -7560,6 +7294,29 @@
         </p:nvPicPr>
         <p:blipFill>
           <a:blip r:embed="rId2"/>
+          <a:srcRect l="0" r="0" t="0" b="0"/>
+          <a:stretch/>
+        </p:blipFill>
+        <p:spPr>
+          <a:xfrm>
+            <a:off x="5156200" y="4502150"/>
+            <a:ext cx="6223000" cy="1926167"/>
+          </a:xfrm>
+          <a:prstGeom prst="rect">
+            <a:avLst/>
+          </a:prstGeom>
+        </p:spPr>
+      </p:pic>
+      <p:pic>
+        <p:nvPicPr>
+          <p:cNvPr id="15" name="Image 2" descr="/Users/bellavg/ProjectsMSc/ai4mi_project/.claude/worktrees/segthor-presentation-midpoint-825c66/deck/assets/uva_logo.png">    </p:cNvPr>
+          <p:cNvPicPr>
+            <a:picLocks noChangeAspect="1"/>
+          </p:cNvPicPr>
+          <p:nvPr/>
+        </p:nvPicPr>
+        <p:blipFill>
+          <a:blip r:embed="rId3"/>
           <a:stretch>
             <a:fillRect/>
           </a:stretch>
@@ -7576,7 +7333,7 @@
       </p:pic>
       <p:sp>
         <p:nvSpPr>
-          <p:cNvPr id="19" name="Text 15"/>
+          <p:cNvPr id="16" name="Text 11"/>
           <p:cNvSpPr txBox="1"/>
           <p:nvPr/>
         </p:nvSpPr>

</xml_diff>

<commit_message>
Deck: contact strip moved to the appendix, spatial slide layout updated
</commit_message>
<xml_diff>
--- a/deck/midproject_outline.pptx
+++ b/deck/midproject_outline.pptx
@@ -3478,7 +3478,7 @@
       </p:sp>
       <p:pic>
         <p:nvPicPr>
-          <p:cNvPr id="7" name="Image 0" descr="/Users/bellavg/ProjectsMSc/ai4mi_project/.claude/worktrees/segthor-presentation-midpoint-825c66/deck/assets/uva_logo.png">    </p:cNvPr>
+          <p:cNvPr id="7" name="Image 0" descr="/Users/bellavg/ProjectsMSc/ai4mi_project/.claude/worktrees/segthor-presentation-midpoint-825c66/figures/profile/label_pairs/label_pairs_strip.png">    </p:cNvPr>
           <p:cNvPicPr>
             <a:picLocks noChangeAspect="1"/>
           </p:cNvPicPr>
@@ -3486,6 +3486,29 @@
         </p:nvPicPr>
         <p:blipFill>
           <a:blip r:embed="rId1"/>
+          <a:srcRect l="0" r="0" t="0" b="0"/>
+          <a:stretch/>
+        </p:blipFill>
+        <p:spPr>
+          <a:xfrm>
+            <a:off x="640080" y="3383280"/>
+            <a:ext cx="8887968" cy="2751038"/>
+          </a:xfrm>
+          <a:prstGeom prst="rect">
+            <a:avLst/>
+          </a:prstGeom>
+        </p:spPr>
+      </p:pic>
+      <p:pic>
+        <p:nvPicPr>
+          <p:cNvPr id="8" name="Image 1" descr="/Users/bellavg/ProjectsMSc/ai4mi_project/.claude/worktrees/segthor-presentation-midpoint-825c66/deck/assets/uva_logo.png">    </p:cNvPr>
+          <p:cNvPicPr>
+            <a:picLocks noChangeAspect="1"/>
+          </p:cNvPicPr>
+          <p:nvPr/>
+        </p:nvPicPr>
+        <p:blipFill>
+          <a:blip r:embed="rId2"/>
           <a:stretch>
             <a:fillRect/>
           </a:stretch>
@@ -3502,7 +3525,7 @@
       </p:pic>
       <p:sp>
         <p:nvSpPr>
-          <p:cNvPr id="8" name="Text 5"/>
+          <p:cNvPr id="9" name="Text 5"/>
           <p:cNvSpPr txBox="1"/>
           <p:nvPr/>
         </p:nvSpPr>
@@ -7022,8 +7045,8 @@
         </p:blipFill>
         <p:spPr>
           <a:xfrm>
-            <a:off x="699371" y="1631950"/>
-            <a:ext cx="8815614" cy="2870200"/>
+            <a:off x="898808" y="1585532"/>
+            <a:ext cx="10245031" cy="3335592"/>
           </a:xfrm>
           <a:prstGeom prst="rect">
             <a:avLst/>
@@ -7032,54 +7055,14 @@
       </p:pic>
       <p:sp>
         <p:nvSpPr>
-          <p:cNvPr id="8" name="Shape 5"/>
-          <p:cNvSpPr/>
-          <p:nvPr/>
-        </p:nvSpPr>
-        <p:spPr>
-          <a:xfrm>
-            <a:off x="9804908" y="1835150"/>
-            <a:ext cx="1574356" cy="2518791"/>
-          </a:xfrm>
-          <a:prstGeom prst="rect">
-            <a:avLst/>
-          </a:prstGeom>
-          <a:solidFill>
-            <a:srgbClr val="FCEEDC"/>
-          </a:solidFill>
-          <a:ln/>
-        </p:spPr>
-      </p:sp>
-      <p:sp>
-        <p:nvSpPr>
-          <p:cNvPr id="9" name="Shape 6"/>
-          <p:cNvSpPr/>
-          <p:nvPr/>
-        </p:nvSpPr>
-        <p:spPr>
-          <a:xfrm>
-            <a:off x="9804908" y="1835150"/>
-            <a:ext cx="54864" cy="2518791"/>
-          </a:xfrm>
-          <a:prstGeom prst="rect">
-            <a:avLst/>
-          </a:prstGeom>
-          <a:solidFill>
-            <a:srgbClr val="E98300"/>
-          </a:solidFill>
-          <a:ln/>
-        </p:spPr>
-      </p:sp>
-      <p:sp>
-        <p:nvSpPr>
-          <p:cNvPr id="10" name="Text 7"/>
-          <p:cNvSpPr txBox="1"/>
-          <p:nvPr/>
-        </p:nvSpPr>
-        <p:spPr>
-          <a:xfrm>
-            <a:off x="10079228" y="2018030"/>
-            <a:ext cx="1025716" cy="274320"/>
+          <p:cNvPr id="8" name="Text 5"/>
+          <p:cNvSpPr txBox="1"/>
+          <p:nvPr/>
+        </p:nvSpPr>
+        <p:spPr>
+          <a:xfrm>
+            <a:off x="1271397" y="5100955"/>
+            <a:ext cx="3610229" cy="256032"/>
           </a:xfrm>
           <a:prstGeom prst="rect">
             <a:avLst/>
@@ -7095,7 +7078,7 @@
               <a:buNone/>
             </a:pPr>
             <a:r>
-              <a:rPr lang="en-US" sz="1100" b="1" spc="100" kern="0" dirty="0">
+              <a:rPr lang="en-US" sz="1150" b="1" spc="100" kern="0" dirty="0">
                 <a:solidFill>
                   <a:srgbClr val="E98300"/>
                 </a:solidFill>
@@ -7103,87 +7086,6 @@
                 <a:ea typeface="Times New Roman" pitchFamily="34" charset="-122"/>
                 <a:cs typeface="Times New Roman" pitchFamily="34" charset="-120"/>
               </a:rPr>
-              <a:t>WHY THIS MATTERS</a:t>
-            </a:r>
-            <a:endParaRPr lang="en-US" sz="1100" dirty="0"/>
-          </a:p>
-        </p:txBody>
-      </p:sp>
-      <p:sp>
-        <p:nvSpPr>
-          <p:cNvPr id="11" name="Text 8"/>
-          <p:cNvSpPr txBox="1"/>
-          <p:nvPr/>
-        </p:nvSpPr>
-        <p:spPr>
-          <a:xfrm>
-            <a:off x="10079228" y="2338070"/>
-            <a:ext cx="1025716" cy="1832991"/>
-          </a:xfrm>
-          <a:prstGeom prst="rect">
-            <a:avLst/>
-          </a:prstGeom>
-          <a:noFill/>
-          <a:ln/>
-        </p:spPr>
-        <p:txBody>
-          <a:bodyPr wrap="square" lIns="0" tIns="0" rIns="0" bIns="0" rtlCol="0" anchor="t"/>
-          <a:lstStyle/>
-          <a:p>
-            <a:pPr indent="0" marL="0">
-              <a:lnSpc>
-                <a:spcPct val="118000"/>
-              </a:lnSpc>
-              <a:buNone/>
-            </a:pPr>
-            <a:r>
-              <a:rPr lang="en-US" sz="1350" dirty="0">
-                <a:solidFill>
-                  <a:srgbClr val="1F1D21"/>
-                </a:solidFill>
-                <a:latin typeface="Times New Roman" pitchFamily="34" charset="0"/>
-                <a:ea typeface="Times New Roman" pitchFamily="34" charset="-122"/>
-                <a:cs typeface="Times New Roman" pitchFamily="34" charset="-120"/>
-              </a:rPr>
-              <a:t>[TODO] how position and extent inform the preprocessing decisions on the next slide.</a:t>
-            </a:r>
-            <a:endParaRPr lang="en-US" sz="1350" dirty="0"/>
-          </a:p>
-        </p:txBody>
-      </p:sp>
-      <p:sp>
-        <p:nvSpPr>
-          <p:cNvPr id="12" name="Text 9"/>
-          <p:cNvSpPr txBox="1"/>
-          <p:nvPr/>
-        </p:nvSpPr>
-        <p:spPr>
-          <a:xfrm>
-            <a:off x="1142810" y="4746689"/>
-            <a:ext cx="3610229" cy="256032"/>
-          </a:xfrm>
-          <a:prstGeom prst="rect">
-            <a:avLst/>
-          </a:prstGeom>
-          <a:noFill/>
-          <a:ln/>
-        </p:spPr>
-        <p:txBody>
-          <a:bodyPr wrap="square" lIns="0" tIns="0" rIns="0" bIns="0" rtlCol="0" anchor="ctr"/>
-          <a:lstStyle/>
-          <a:p>
-            <a:pPr indent="0" marL="0">
-              <a:buNone/>
-            </a:pPr>
-            <a:r>
-              <a:rPr lang="en-US" sz="1150" b="1" spc="100" kern="0" dirty="0">
-                <a:solidFill>
-                  <a:srgbClr val="E98300"/>
-                </a:solidFill>
-                <a:latin typeface="Times New Roman" pitchFamily="34" charset="0"/>
-                <a:ea typeface="Times New Roman" pitchFamily="34" charset="-122"/>
-                <a:cs typeface="Times New Roman" pitchFamily="34" charset="-120"/>
-              </a:rPr>
               <a:t>POSITION, EXTENT &amp; ADJACENCY</a:t>
             </a:r>
             <a:endParaRPr lang="en-US" sz="1150" dirty="0"/>
@@ -7192,13 +7094,13 @@
       </p:sp>
       <p:sp>
         <p:nvSpPr>
-          <p:cNvPr id="13" name="Text 10"/>
-          <p:cNvSpPr txBox="1"/>
-          <p:nvPr/>
-        </p:nvSpPr>
-        <p:spPr>
-          <a:xfrm>
-            <a:off x="1142810" y="5039297"/>
+          <p:cNvPr id="9" name="Text 6"/>
+          <p:cNvSpPr txBox="1"/>
+          <p:nvPr/>
+        </p:nvSpPr>
+        <p:spPr>
+          <a:xfrm>
+            <a:off x="1271397" y="5393563"/>
             <a:ext cx="3610229" cy="1014984"/>
           </a:xfrm>
           <a:prstGeom prst="rect">
@@ -7284,9 +7186,130 @@
           </a:p>
         </p:txBody>
       </p:sp>
+      <p:sp>
+        <p:nvSpPr>
+          <p:cNvPr id="10" name="Shape 7"/>
+          <p:cNvSpPr/>
+          <p:nvPr/>
+        </p:nvSpPr>
+        <p:spPr>
+          <a:xfrm>
+            <a:off x="7165912" y="5100955"/>
+            <a:ext cx="4064000" cy="1188720"/>
+          </a:xfrm>
+          <a:prstGeom prst="rect">
+            <a:avLst/>
+          </a:prstGeom>
+          <a:solidFill>
+            <a:srgbClr val="FCEEDC"/>
+          </a:solidFill>
+          <a:ln/>
+        </p:spPr>
+      </p:sp>
+      <p:sp>
+        <p:nvSpPr>
+          <p:cNvPr id="11" name="Shape 8"/>
+          <p:cNvSpPr/>
+          <p:nvPr/>
+        </p:nvSpPr>
+        <p:spPr>
+          <a:xfrm>
+            <a:off x="7165912" y="5100955"/>
+            <a:ext cx="54864" cy="1188720"/>
+          </a:xfrm>
+          <a:prstGeom prst="rect">
+            <a:avLst/>
+          </a:prstGeom>
+          <a:solidFill>
+            <a:srgbClr val="E98300"/>
+          </a:solidFill>
+          <a:ln/>
+        </p:spPr>
+      </p:sp>
+      <p:sp>
+        <p:nvSpPr>
+          <p:cNvPr id="12" name="Text 9"/>
+          <p:cNvSpPr txBox="1"/>
+          <p:nvPr/>
+        </p:nvSpPr>
+        <p:spPr>
+          <a:xfrm>
+            <a:off x="7440232" y="5283835"/>
+            <a:ext cx="3515360" cy="274320"/>
+          </a:xfrm>
+          <a:prstGeom prst="rect">
+            <a:avLst/>
+          </a:prstGeom>
+          <a:noFill/>
+          <a:ln/>
+        </p:spPr>
+        <p:txBody>
+          <a:bodyPr wrap="square" lIns="0" tIns="0" rIns="0" bIns="0" rtlCol="0" anchor="ctr"/>
+          <a:lstStyle/>
+          <a:p>
+            <a:pPr indent="0" marL="0">
+              <a:buNone/>
+            </a:pPr>
+            <a:r>
+              <a:rPr lang="en-US" sz="1100" b="1" spc="100" kern="0" dirty="0">
+                <a:solidFill>
+                  <a:srgbClr val="E98300"/>
+                </a:solidFill>
+                <a:latin typeface="Times New Roman" pitchFamily="34" charset="0"/>
+                <a:ea typeface="Times New Roman" pitchFamily="34" charset="-122"/>
+                <a:cs typeface="Times New Roman" pitchFamily="34" charset="-120"/>
+              </a:rPr>
+              <a:t>WHY THIS MATTERS</a:t>
+            </a:r>
+            <a:endParaRPr lang="en-US" sz="1100" dirty="0"/>
+          </a:p>
+        </p:txBody>
+      </p:sp>
+      <p:sp>
+        <p:nvSpPr>
+          <p:cNvPr id="13" name="Text 10"/>
+          <p:cNvSpPr txBox="1"/>
+          <p:nvPr/>
+        </p:nvSpPr>
+        <p:spPr>
+          <a:xfrm>
+            <a:off x="7440232" y="5603875"/>
+            <a:ext cx="3515360" cy="502920"/>
+          </a:xfrm>
+          <a:prstGeom prst="rect">
+            <a:avLst/>
+          </a:prstGeom>
+          <a:noFill/>
+          <a:ln/>
+        </p:spPr>
+        <p:txBody>
+          <a:bodyPr wrap="square" lIns="0" tIns="0" rIns="0" bIns="0" rtlCol="0" anchor="t"/>
+          <a:lstStyle/>
+          <a:p>
+            <a:pPr indent="0" marL="0">
+              <a:lnSpc>
+                <a:spcPct val="118000"/>
+              </a:lnSpc>
+              <a:buNone/>
+            </a:pPr>
+            <a:r>
+              <a:rPr lang="en-US" sz="1350" dirty="0">
+                <a:solidFill>
+                  <a:srgbClr val="1F1D21"/>
+                </a:solidFill>
+                <a:latin typeface="Times New Roman" pitchFamily="34" charset="0"/>
+                <a:ea typeface="Times New Roman" pitchFamily="34" charset="-122"/>
+                <a:cs typeface="Times New Roman" pitchFamily="34" charset="-120"/>
+              </a:rPr>
+              <a:t>[TODO] how position and extent inform the preprocessing decisions on the next slide.</a:t>
+            </a:r>
+            <a:endParaRPr lang="en-US" sz="1350" dirty="0"/>
+          </a:p>
+        </p:txBody>
+      </p:sp>
       <p:pic>
         <p:nvPicPr>
-          <p:cNvPr id="14" name="Image 1" descr="/Users/bellavg/ProjectsMSc/ai4mi_project/.claude/worktrees/segthor-presentation-midpoint-825c66/figures/profile/label_pairs/label_pairs_strip.png">    </p:cNvPr>
+          <p:cNvPr id="14" name="Image 1" descr="/Users/bellavg/ProjectsMSc/ai4mi_project/.claude/worktrees/segthor-presentation-midpoint-825c66/deck/assets/uva_logo.png">    </p:cNvPr>
           <p:cNvPicPr>
             <a:picLocks noChangeAspect="1"/>
           </p:cNvPicPr>
@@ -7294,29 +7317,6 @@
         </p:nvPicPr>
         <p:blipFill>
           <a:blip r:embed="rId2"/>
-          <a:srcRect l="0" r="0" t="0" b="0"/>
-          <a:stretch/>
-        </p:blipFill>
-        <p:spPr>
-          <a:xfrm>
-            <a:off x="5156200" y="4502150"/>
-            <a:ext cx="6223000" cy="1926167"/>
-          </a:xfrm>
-          <a:prstGeom prst="rect">
-            <a:avLst/>
-          </a:prstGeom>
-        </p:spPr>
-      </p:pic>
-      <p:pic>
-        <p:nvPicPr>
-          <p:cNvPr id="15" name="Image 2" descr="/Users/bellavg/ProjectsMSc/ai4mi_project/.claude/worktrees/segthor-presentation-midpoint-825c66/deck/assets/uva_logo.png">    </p:cNvPr>
-          <p:cNvPicPr>
-            <a:picLocks noChangeAspect="1"/>
-          </p:cNvPicPr>
-          <p:nvPr/>
-        </p:nvPicPr>
-        <p:blipFill>
-          <a:blip r:embed="rId3"/>
           <a:stretch>
             <a:fillRect/>
           </a:stretch>
@@ -7333,7 +7333,7 @@
       </p:pic>
       <p:sp>
         <p:nvSpPr>
-          <p:cNvPr id="16" name="Text 11"/>
+          <p:cNvPr id="15" name="Text 11"/>
           <p:cNvSpPr txBox="1"/>
           <p:nvPr/>
         </p:nvSpPr>

</xml_diff>

<commit_message>
Deck: baseline layout with comparison grid, figure frames on the modification slide
</commit_message>
<xml_diff>
--- a/deck/midproject_outline.pptx
+++ b/deck/midproject_outline.pptx
@@ -2370,7 +2370,7 @@
         <p:spPr>
           <a:xfrm>
             <a:off x="640080" y="3154680"/>
-            <a:ext cx="2514600" cy="2743200"/>
+            <a:ext cx="2514600" cy="868680"/>
           </a:xfrm>
           <a:prstGeom prst="rect">
             <a:avLst/>
@@ -2530,7 +2530,7 @@
         <p:spPr>
           <a:xfrm>
             <a:off x="3429000" y="3154680"/>
-            <a:ext cx="2514600" cy="2743200"/>
+            <a:ext cx="2514600" cy="868680"/>
           </a:xfrm>
           <a:prstGeom prst="rect">
             <a:avLst/>
@@ -2690,7 +2690,7 @@
         <p:spPr>
           <a:xfrm>
             <a:off x="6217920" y="3154680"/>
-            <a:ext cx="2514600" cy="2743200"/>
+            <a:ext cx="2514600" cy="868680"/>
           </a:xfrm>
           <a:prstGeom prst="rect">
             <a:avLst/>
@@ -2850,7 +2850,7 @@
         <p:spPr>
           <a:xfrm>
             <a:off x="9006840" y="3154680"/>
-            <a:ext cx="2514600" cy="2743200"/>
+            <a:ext cx="2514600" cy="868680"/>
           </a:xfrm>
           <a:prstGeom prst="rect">
             <a:avLst/>
@@ -2883,9 +2883,137 @@
           </a:p>
         </p:txBody>
       </p:sp>
+      <p:sp>
+        <p:nvSpPr>
+          <p:cNvPr id="26" name="Shape 24"/>
+          <p:cNvSpPr/>
+          <p:nvPr/>
+        </p:nvSpPr>
+        <p:spPr>
+          <a:xfrm>
+            <a:off x="640080" y="4102100"/>
+            <a:ext cx="5143500" cy="1905000"/>
+          </a:xfrm>
+          <a:prstGeom prst="rect">
+            <a:avLst/>
+          </a:prstGeom>
+          <a:solidFill>
+            <a:srgbClr val="FFFFFF"/>
+          </a:solidFill>
+          <a:ln w="19050">
+            <a:solidFill>
+              <a:srgbClr val="CDBFCB"/>
+            </a:solidFill>
+            <a:prstDash val="dash"/>
+          </a:ln>
+        </p:spPr>
+      </p:sp>
+      <p:sp>
+        <p:nvSpPr>
+          <p:cNvPr id="27" name="Text 25"/>
+          <p:cNvSpPr txBox="1"/>
+          <p:nvPr/>
+        </p:nvSpPr>
+        <p:spPr>
+          <a:xfrm>
+            <a:off x="640080" y="6061964"/>
+            <a:ext cx="5143500" cy="320040"/>
+          </a:xfrm>
+          <a:prstGeom prst="rect">
+            <a:avLst/>
+          </a:prstGeom>
+          <a:noFill/>
+          <a:ln/>
+        </p:spPr>
+        <p:txBody>
+          <a:bodyPr wrap="square" lIns="0" tIns="0" rIns="0" bIns="0" rtlCol="0" anchor="ctr"/>
+          <a:lstStyle/>
+          <a:p>
+            <a:pPr indent="0" marL="0">
+              <a:buNone/>
+            </a:pPr>
+            <a:r>
+              <a:rPr lang="en-US" sz="1200" i="1" dirty="0">
+                <a:solidFill>
+                  <a:srgbClr val="6B6B6B"/>
+                </a:solidFill>
+                <a:latin typeface="Times New Roman" pitchFamily="34" charset="0"/>
+                <a:ea typeface="Times New Roman" pitchFamily="34" charset="-122"/>
+                <a:cs typeface="Times New Roman" pitchFamily="34" charset="-120"/>
+              </a:rPr>
+              <a:t>[TODO] figure 1: results vs. corrected baseline (and nnU-Net)</a:t>
+            </a:r>
+            <a:endParaRPr lang="en-US" sz="1200" dirty="0"/>
+          </a:p>
+        </p:txBody>
+      </p:sp>
+      <p:sp>
+        <p:nvSpPr>
+          <p:cNvPr id="28" name="Shape 26"/>
+          <p:cNvSpPr/>
+          <p:nvPr/>
+        </p:nvSpPr>
+        <p:spPr>
+          <a:xfrm>
+            <a:off x="6061964" y="4102100"/>
+            <a:ext cx="5143500" cy="1905000"/>
+          </a:xfrm>
+          <a:prstGeom prst="rect">
+            <a:avLst/>
+          </a:prstGeom>
+          <a:solidFill>
+            <a:srgbClr val="FFFFFF"/>
+          </a:solidFill>
+          <a:ln w="19050">
+            <a:solidFill>
+              <a:srgbClr val="CDBFCB"/>
+            </a:solidFill>
+            <a:prstDash val="dash"/>
+          </a:ln>
+        </p:spPr>
+      </p:sp>
+      <p:sp>
+        <p:nvSpPr>
+          <p:cNvPr id="29" name="Text 27"/>
+          <p:cNvSpPr txBox="1"/>
+          <p:nvPr/>
+        </p:nvSpPr>
+        <p:spPr>
+          <a:xfrm>
+            <a:off x="6061964" y="6061964"/>
+            <a:ext cx="5143500" cy="320040"/>
+          </a:xfrm>
+          <a:prstGeom prst="rect">
+            <a:avLst/>
+          </a:prstGeom>
+          <a:noFill/>
+          <a:ln/>
+        </p:spPr>
+        <p:txBody>
+          <a:bodyPr wrap="square" lIns="0" tIns="0" rIns="0" bIns="0" rtlCol="0" anchor="ctr"/>
+          <a:lstStyle/>
+          <a:p>
+            <a:pPr indent="0" marL="0">
+              <a:buNone/>
+            </a:pPr>
+            <a:r>
+              <a:rPr lang="en-US" sz="1200" i="1" dirty="0">
+                <a:solidFill>
+                  <a:srgbClr val="6B6B6B"/>
+                </a:solidFill>
+                <a:latin typeface="Times New Roman" pitchFamily="34" charset="0"/>
+                <a:ea typeface="Times New Roman" pitchFamily="34" charset="-122"/>
+                <a:cs typeface="Times New Roman" pitchFamily="34" charset="-120"/>
+              </a:rPr>
+              <a:t>[TODO] figure 2: ground truth vs. baseline vs. modified prediction</a:t>
+            </a:r>
+            <a:endParaRPr lang="en-US" sz="1200" dirty="0"/>
+          </a:p>
+        </p:txBody>
+      </p:sp>
       <p:pic>
         <p:nvPicPr>
-          <p:cNvPr id="26" name="Image 0" descr="/Users/bellavg/ProjectsMSc/ai4mi_project/.claude/worktrees/segthor-presentation-midpoint-825c66/deck/assets/uva_logo.png">    </p:cNvPr>
+          <p:cNvPr id="30" name="Image 0" descr="/Users/bellavg/ProjectsMSc/ai4mi_project/.claude/worktrees/segthor-presentation-midpoint-825c66/deck/assets/uva_logo.png">    </p:cNvPr>
           <p:cNvPicPr>
             <a:picLocks noChangeAspect="1"/>
           </p:cNvPicPr>
@@ -2909,7 +3037,7 @@
       </p:pic>
       <p:sp>
         <p:nvSpPr>
-          <p:cNvPr id="27" name="Text 24"/>
+          <p:cNvPr id="31" name="Text 28"/>
           <p:cNvSpPr txBox="1"/>
           <p:nvPr/>
         </p:nvSpPr>
@@ -8273,60 +8401,55 @@
       </p:sp>
       <p:sp>
         <p:nvSpPr>
-          <p:cNvPr id="7" name="Text 5"/>
-          <p:cNvSpPr txBox="1"/>
-          <p:nvPr/>
-        </p:nvSpPr>
-        <p:spPr>
-          <a:xfrm>
-            <a:off x="640080" y="1783080"/>
-            <a:ext cx="6309360" cy="4206240"/>
-          </a:xfrm>
-          <a:prstGeom prst="rect">
-            <a:avLst/>
-          </a:prstGeom>
-          <a:noFill/>
-          <a:ln/>
-        </p:spPr>
-        <p:txBody>
-          <a:bodyPr wrap="square" lIns="0" tIns="0" rIns="0" bIns="0" rtlCol="0" anchor="t"/>
-          <a:lstStyle/>
-          <a:p>
-            <a:pPr marL="228600" indent="-228600">
-              <a:lnSpc>
-                <a:spcPct val="118000"/>
-              </a:lnSpc>
-              <a:spcAft>
-                <a:spcPts val="1400"/>
-              </a:spcAft>
-              <a:buSzPct val="100000"/>
-              <a:buChar char="▪"/>
-            </a:pPr>
-            <a:r>
-              <a:rPr lang="en-US" sz="1600" b="1" dirty="0">
-                <a:solidFill>
-                  <a:srgbClr val="1F1D21"/>
-                </a:solidFill>
-                <a:latin typeface="Times New Roman" pitchFamily="34" charset="0"/>
-                <a:ea typeface="Times New Roman" pitchFamily="34" charset="-122"/>
-                <a:cs typeface="Times New Roman" pitchFamily="34" charset="-120"/>
-              </a:rPr>
-              <a:t>Split: 15 train / 5 val — val = patients 01, 11, 15, 17, 19</a:t>
-            </a:r>
-            <a:endParaRPr lang="en-US" sz="1600" dirty="0"/>
-          </a:p>
-          <a:p>
-            <a:pPr lvl="1" indent="0" marL="0">
-              <a:lnSpc>
-                <a:spcPct val="118000"/>
-              </a:lnSpc>
-              <a:spcAft>
-                <a:spcPts val="600"/>
-              </a:spcAft>
-              <a:buNone/>
-            </a:pPr>
-            <a:r>
-              <a:rPr lang="en-US" sz="1400" dirty="0">
+          <p:cNvPr id="7" name="Shape 5"/>
+          <p:cNvSpPr/>
+          <p:nvPr/>
+        </p:nvSpPr>
+        <p:spPr>
+          <a:xfrm>
+            <a:off x="639064" y="1689100"/>
+            <a:ext cx="6223000" cy="3175000"/>
+          </a:xfrm>
+          <a:prstGeom prst="rect">
+            <a:avLst/>
+          </a:prstGeom>
+          <a:solidFill>
+            <a:srgbClr val="FFFFFF"/>
+          </a:solidFill>
+          <a:ln w="19050">
+            <a:solidFill>
+              <a:srgbClr val="C9B3C6"/>
+            </a:solidFill>
+            <a:prstDash val="dash"/>
+          </a:ln>
+        </p:spPr>
+      </p:sp>
+      <p:sp>
+        <p:nvSpPr>
+          <p:cNvPr id="8" name="Text 6"/>
+          <p:cNvSpPr txBox="1"/>
+          <p:nvPr/>
+        </p:nvSpPr>
+        <p:spPr>
+          <a:xfrm>
+            <a:off x="639064" y="1689100"/>
+            <a:ext cx="6223000" cy="3175000"/>
+          </a:xfrm>
+          <a:prstGeom prst="rect">
+            <a:avLst/>
+          </a:prstGeom>
+          <a:noFill/>
+          <a:ln/>
+        </p:spPr>
+        <p:txBody>
+          <a:bodyPr wrap="square" lIns="0" tIns="0" rIns="0" bIns="0" rtlCol="0" anchor="ctr"/>
+          <a:lstStyle/>
+          <a:p>
+            <a:pPr algn="ctr" indent="0" marL="0">
+              <a:buNone/>
+            </a:pPr>
+            <a:r>
+              <a:rPr lang="en-US" sz="1200" i="1" dirty="0">
                 <a:solidFill>
                   <a:srgbClr val="6B6B6B"/>
                 </a:solidFill>
@@ -8334,22 +8457,22 @@
                 <a:ea typeface="Times New Roman" pitchFamily="34" charset="-122"/>
                 <a:cs typeface="Times New Roman" pitchFamily="34" charset="-120"/>
               </a:rPr>
-              <a:t>Scores below are means over these 5 held-out scans</a:t>
-            </a:r>
-            <a:endParaRPr lang="en-US" sz="1600" dirty="0"/>
-          </a:p>
-        </p:txBody>
-      </p:sp>
-      <p:sp>
-        <p:nvSpPr>
-          <p:cNvPr id="8" name="Shape 6"/>
+              <a:t>Ground truth vs. prediction on a validation patient (figure to add)</a:t>
+            </a:r>
+            <a:endParaRPr lang="en-US" sz="1200" dirty="0"/>
+          </a:p>
+        </p:txBody>
+      </p:sp>
+      <p:sp>
+        <p:nvSpPr>
+          <p:cNvPr id="9" name="Shape 7"/>
           <p:cNvSpPr/>
           <p:nvPr/>
         </p:nvSpPr>
         <p:spPr>
           <a:xfrm>
-            <a:off x="7360920" y="1783080"/>
-            <a:ext cx="4160520" cy="2011680"/>
+            <a:off x="639064" y="4991100"/>
+            <a:ext cx="6223000" cy="1371600"/>
           </a:xfrm>
           <a:prstGeom prst="rect">
             <a:avLst/>
@@ -8362,14 +8485,14 @@
       </p:sp>
       <p:sp>
         <p:nvSpPr>
-          <p:cNvPr id="9" name="Shape 7"/>
+          <p:cNvPr id="10" name="Shape 8"/>
           <p:cNvSpPr/>
           <p:nvPr/>
         </p:nvSpPr>
         <p:spPr>
           <a:xfrm>
-            <a:off x="7360920" y="1783080"/>
-            <a:ext cx="54864" cy="2011680"/>
+            <a:off x="639064" y="4991100"/>
+            <a:ext cx="54864" cy="1371600"/>
           </a:xfrm>
           <a:prstGeom prst="rect">
             <a:avLst/>
@@ -8382,14 +8505,14 @@
       </p:sp>
       <p:sp>
         <p:nvSpPr>
-          <p:cNvPr id="10" name="Text 8"/>
-          <p:cNvSpPr txBox="1"/>
-          <p:nvPr/>
-        </p:nvSpPr>
-        <p:spPr>
-          <a:xfrm>
-            <a:off x="7635240" y="1965960"/>
-            <a:ext cx="3611880" cy="274320"/>
+          <p:cNvPr id="11" name="Text 9"/>
+          <p:cNvSpPr txBox="1"/>
+          <p:nvPr/>
+        </p:nvSpPr>
+        <p:spPr>
+          <a:xfrm>
+            <a:off x="913384" y="5173980"/>
+            <a:ext cx="5674360" cy="274320"/>
           </a:xfrm>
           <a:prstGeom prst="rect">
             <a:avLst/>
@@ -8413,7 +8536,7 @@
                 <a:ea typeface="Times New Roman" pitchFamily="34" charset="-122"/>
                 <a:cs typeface="Times New Roman" pitchFamily="34" charset="-120"/>
               </a:rPr>
-              <a:t>POSITIVE-SLICE DICE (PATIENT MEANS)</a:t>
+              <a:t>BASELINE: POSITIVE-SLICE DICE (PATIENT MEANS)</a:t>
             </a:r>
             <a:endParaRPr lang="en-US" sz="1100" dirty="0"/>
           </a:p>
@@ -8421,14 +8544,14 @@
       </p:sp>
       <p:sp>
         <p:nvSpPr>
-          <p:cNvPr id="11" name="Text 9"/>
-          <p:cNvSpPr txBox="1"/>
-          <p:nvPr/>
-        </p:nvSpPr>
-        <p:spPr>
-          <a:xfrm>
-            <a:off x="7635240" y="2286000"/>
-            <a:ext cx="3611880" cy="1325880"/>
+          <p:cNvPr id="12" name="Text 10"/>
+          <p:cNvSpPr txBox="1"/>
+          <p:nvPr/>
+        </p:nvSpPr>
+        <p:spPr>
+          <a:xfrm>
+            <a:off x="913384" y="5494020"/>
+            <a:ext cx="5674360" cy="685800"/>
           </a:xfrm>
           <a:prstGeom prst="rect">
             <a:avLst/>
@@ -8455,7 +8578,7 @@
                 <a:ea typeface="Times New Roman" pitchFamily="34" charset="-122"/>
                 <a:cs typeface="Times New Roman" pitchFamily="34" charset="-120"/>
               </a:rPr>
-              <a:t>Esophagus: 0.47</a:t>
+              <a:t>Esophagus 0.47 · Heart 0.58 · Trachea 0.50</a:t>
             </a:r>
             <a:endParaRPr lang="en-US" sz="1350" dirty="0"/>
           </a:p>
@@ -8475,19 +8598,496 @@
                 <a:ea typeface="Times New Roman" pitchFamily="34" charset="-122"/>
                 <a:cs typeface="Times New Roman" pitchFamily="34" charset="-120"/>
               </a:rPr>
-              <a:t>Heart: 0.58</a:t>
+              <a:t>Split: 15 train / 5 val (val = patients 01, 11, 15, 17, 19); scores are means over these 5 held-out scans</a:t>
             </a:r>
             <a:endParaRPr lang="en-US" sz="1350" dirty="0"/>
           </a:p>
+        </p:txBody>
+      </p:sp>
+      <p:sp>
+        <p:nvSpPr>
+          <p:cNvPr id="13" name="Text 11"/>
+          <p:cNvSpPr txBox="1"/>
+          <p:nvPr/>
+        </p:nvSpPr>
+        <p:spPr>
+          <a:xfrm>
+            <a:off x="7192264" y="1689100"/>
+            <a:ext cx="4013200" cy="502920"/>
+          </a:xfrm>
+          <a:prstGeom prst="rect">
+            <a:avLst/>
+          </a:prstGeom>
+          <a:noFill/>
+          <a:ln/>
+        </p:spPr>
+        <p:txBody>
+          <a:bodyPr wrap="square" lIns="0" tIns="0" rIns="0" bIns="0" rtlCol="0" anchor="t"/>
+          <a:lstStyle/>
           <a:p>
             <a:pPr indent="0" marL="0">
+              <a:buNone/>
+            </a:pPr>
+            <a:r>
+              <a:rPr lang="en-US" sz="1150" b="1" spc="100" kern="0" dirty="0">
+                <a:solidFill>
+                  <a:srgbClr val="751B68"/>
+                </a:solidFill>
+                <a:latin typeface="Times New Roman" pitchFamily="34" charset="0"/>
+                <a:ea typeface="Times New Roman" pitchFamily="34" charset="-122"/>
+                <a:cs typeface="Times New Roman" pitchFamily="34" charset="-120"/>
+              </a:rPr>
+              <a:t>UNCORRECTED VS. CORRECTED LABELS, WITH VS. WITHOUT PREPROCESSING</a:t>
+            </a:r>
+            <a:endParaRPr lang="en-US" sz="1150" dirty="0"/>
+          </a:p>
+        </p:txBody>
+      </p:sp>
+      <p:sp>
+        <p:nvSpPr>
+          <p:cNvPr id="14" name="Text 12"/>
+          <p:cNvSpPr txBox="1"/>
+          <p:nvPr/>
+        </p:nvSpPr>
+        <p:spPr>
+          <a:xfrm>
+            <a:off x="8462264" y="2235200"/>
+            <a:ext cx="1371600" cy="508000"/>
+          </a:xfrm>
+          <a:prstGeom prst="rect">
+            <a:avLst/>
+          </a:prstGeom>
+          <a:noFill/>
+          <a:ln/>
+        </p:spPr>
+        <p:txBody>
+          <a:bodyPr wrap="square" lIns="0" tIns="0" rIns="0" bIns="0" rtlCol="0" anchor="ctr"/>
+          <a:lstStyle/>
+          <a:p>
+            <a:pPr algn="ctr" indent="0" marL="0">
+              <a:buNone/>
+            </a:pPr>
+            <a:r>
+              <a:rPr lang="en-US" sz="1200" b="1" dirty="0">
+                <a:solidFill>
+                  <a:srgbClr val="751B68"/>
+                </a:solidFill>
+                <a:latin typeface="Times New Roman" pitchFamily="34" charset="0"/>
+                <a:ea typeface="Times New Roman" pitchFamily="34" charset="-122"/>
+                <a:cs typeface="Times New Roman" pitchFamily="34" charset="-120"/>
+              </a:rPr>
+              <a:t>Without preprocessing</a:t>
+            </a:r>
+            <a:endParaRPr lang="en-US" sz="1200" dirty="0"/>
+          </a:p>
+        </p:txBody>
+      </p:sp>
+      <p:sp>
+        <p:nvSpPr>
+          <p:cNvPr id="15" name="Text 13"/>
+          <p:cNvSpPr txBox="1"/>
+          <p:nvPr/>
+        </p:nvSpPr>
+        <p:spPr>
+          <a:xfrm>
+            <a:off x="9833864" y="2235200"/>
+            <a:ext cx="1371600" cy="508000"/>
+          </a:xfrm>
+          <a:prstGeom prst="rect">
+            <a:avLst/>
+          </a:prstGeom>
+          <a:noFill/>
+          <a:ln/>
+        </p:spPr>
+        <p:txBody>
+          <a:bodyPr wrap="square" lIns="0" tIns="0" rIns="0" bIns="0" rtlCol="0" anchor="ctr"/>
+          <a:lstStyle/>
+          <a:p>
+            <a:pPr algn="ctr" indent="0" marL="0">
+              <a:buNone/>
+            </a:pPr>
+            <a:r>
+              <a:rPr lang="en-US" sz="1200" b="1" dirty="0">
+                <a:solidFill>
+                  <a:srgbClr val="751B68"/>
+                </a:solidFill>
+                <a:latin typeface="Times New Roman" pitchFamily="34" charset="0"/>
+                <a:ea typeface="Times New Roman" pitchFamily="34" charset="-122"/>
+                <a:cs typeface="Times New Roman" pitchFamily="34" charset="-120"/>
+              </a:rPr>
+              <a:t>With preprocessing</a:t>
+            </a:r>
+            <a:endParaRPr lang="en-US" sz="1200" dirty="0"/>
+          </a:p>
+        </p:txBody>
+      </p:sp>
+      <p:sp>
+        <p:nvSpPr>
+          <p:cNvPr id="16" name="Shape 14"/>
+          <p:cNvSpPr/>
+          <p:nvPr/>
+        </p:nvSpPr>
+        <p:spPr>
+          <a:xfrm>
+            <a:off x="8462264" y="2743200"/>
+            <a:ext cx="2743200" cy="18288"/>
+          </a:xfrm>
+          <a:prstGeom prst="rect">
+            <a:avLst/>
+          </a:prstGeom>
+          <a:solidFill>
+            <a:srgbClr val="751B68"/>
+          </a:solidFill>
+          <a:ln/>
+        </p:spPr>
+      </p:sp>
+      <p:sp>
+        <p:nvSpPr>
+          <p:cNvPr id="17" name="Shape 15"/>
+          <p:cNvSpPr/>
+          <p:nvPr/>
+        </p:nvSpPr>
+        <p:spPr>
+          <a:xfrm>
+            <a:off x="8462264" y="2743200"/>
+            <a:ext cx="1371600" cy="889000"/>
+          </a:xfrm>
+          <a:prstGeom prst="rect">
+            <a:avLst/>
+          </a:prstGeom>
+          <a:solidFill>
+            <a:srgbClr val="F1E6EF"/>
+          </a:solidFill>
+          <a:ln/>
+        </p:spPr>
+      </p:sp>
+      <p:sp>
+        <p:nvSpPr>
+          <p:cNvPr id="18" name="Text 16"/>
+          <p:cNvSpPr txBox="1"/>
+          <p:nvPr/>
+        </p:nvSpPr>
+        <p:spPr>
+          <a:xfrm>
+            <a:off x="7192264" y="2743200"/>
+            <a:ext cx="1178560" cy="889000"/>
+          </a:xfrm>
+          <a:prstGeom prst="rect">
+            <a:avLst/>
+          </a:prstGeom>
+          <a:noFill/>
+          <a:ln/>
+        </p:spPr>
+        <p:txBody>
+          <a:bodyPr wrap="square" lIns="0" tIns="0" rIns="0" bIns="0" rtlCol="0" anchor="ctr"/>
+          <a:lstStyle/>
+          <a:p>
+            <a:pPr indent="0" marL="0">
+              <a:buNone/>
+            </a:pPr>
+            <a:r>
+              <a:rPr lang="en-US" sz="1200" b="1" dirty="0">
+                <a:solidFill>
+                  <a:srgbClr val="1F1D21"/>
+                </a:solidFill>
+                <a:latin typeface="Times New Roman" pitchFamily="34" charset="0"/>
+                <a:ea typeface="Times New Roman" pitchFamily="34" charset="-122"/>
+                <a:cs typeface="Times New Roman" pitchFamily="34" charset="-120"/>
+              </a:rPr>
+              <a:t>Uncorrected labels</a:t>
+            </a:r>
+            <a:endParaRPr lang="en-US" sz="1200" dirty="0"/>
+          </a:p>
+        </p:txBody>
+      </p:sp>
+      <p:sp>
+        <p:nvSpPr>
+          <p:cNvPr id="19" name="Text 17"/>
+          <p:cNvSpPr txBox="1"/>
+          <p:nvPr/>
+        </p:nvSpPr>
+        <p:spPr>
+          <a:xfrm>
+            <a:off x="8462264" y="2743200"/>
+            <a:ext cx="1371600" cy="889000"/>
+          </a:xfrm>
+          <a:prstGeom prst="rect">
+            <a:avLst/>
+          </a:prstGeom>
+          <a:noFill/>
+          <a:ln/>
+        </p:spPr>
+        <p:txBody>
+          <a:bodyPr wrap="square" lIns="0" tIns="0" rIns="0" bIns="0" rtlCol="0" anchor="ctr"/>
+          <a:lstStyle/>
+          <a:p>
+            <a:pPr algn="ctr" indent="0" marL="0">
+              <a:buNone/>
+            </a:pPr>
+            <a:r>
+              <a:rPr lang="en-US" sz="1200" dirty="0">
+                <a:solidFill>
+                  <a:srgbClr val="1F1D21"/>
+                </a:solidFill>
+                <a:latin typeface="Times New Roman" pitchFamily="34" charset="0"/>
+                <a:ea typeface="Times New Roman" pitchFamily="34" charset="-122"/>
+                <a:cs typeface="Times New Roman" pitchFamily="34" charset="-120"/>
+              </a:rPr>
+              <a:t>[TODO]</a:t>
+            </a:r>
+            <a:endParaRPr lang="en-US" sz="1200" dirty="0"/>
+          </a:p>
+        </p:txBody>
+      </p:sp>
+      <p:sp>
+        <p:nvSpPr>
+          <p:cNvPr id="20" name="Text 18"/>
+          <p:cNvSpPr txBox="1"/>
+          <p:nvPr/>
+        </p:nvSpPr>
+        <p:spPr>
+          <a:xfrm>
+            <a:off x="9833864" y="2743200"/>
+            <a:ext cx="1371600" cy="889000"/>
+          </a:xfrm>
+          <a:prstGeom prst="rect">
+            <a:avLst/>
+          </a:prstGeom>
+          <a:noFill/>
+          <a:ln/>
+        </p:spPr>
+        <p:txBody>
+          <a:bodyPr wrap="square" lIns="0" tIns="0" rIns="0" bIns="0" rtlCol="0" anchor="ctr"/>
+          <a:lstStyle/>
+          <a:p>
+            <a:pPr algn="ctr" indent="0" marL="0">
+              <a:buNone/>
+            </a:pPr>
+            <a:r>
+              <a:rPr lang="en-US" sz="1200" dirty="0">
+                <a:solidFill>
+                  <a:srgbClr val="1F1D21"/>
+                </a:solidFill>
+                <a:latin typeface="Times New Roman" pitchFamily="34" charset="0"/>
+                <a:ea typeface="Times New Roman" pitchFamily="34" charset="-122"/>
+                <a:cs typeface="Times New Roman" pitchFamily="34" charset="-120"/>
+              </a:rPr>
+              <a:t>[TODO]</a:t>
+            </a:r>
+            <a:endParaRPr lang="en-US" sz="1200" dirty="0"/>
+          </a:p>
+        </p:txBody>
+      </p:sp>
+      <p:sp>
+        <p:nvSpPr>
+          <p:cNvPr id="21" name="Shape 19"/>
+          <p:cNvSpPr/>
+          <p:nvPr/>
+        </p:nvSpPr>
+        <p:spPr>
+          <a:xfrm>
+            <a:off x="7192264" y="3632200"/>
+            <a:ext cx="4013200" cy="9144"/>
+          </a:xfrm>
+          <a:prstGeom prst="rect">
+            <a:avLst/>
+          </a:prstGeom>
+          <a:solidFill>
+            <a:srgbClr val="E3E3E3"/>
+          </a:solidFill>
+          <a:ln/>
+        </p:spPr>
+      </p:sp>
+      <p:sp>
+        <p:nvSpPr>
+          <p:cNvPr id="22" name="Shape 20"/>
+          <p:cNvSpPr/>
+          <p:nvPr/>
+        </p:nvSpPr>
+        <p:spPr>
+          <a:xfrm>
+            <a:off x="8462264" y="3632200"/>
+            <a:ext cx="1371600" cy="889000"/>
+          </a:xfrm>
+          <a:prstGeom prst="rect">
+            <a:avLst/>
+          </a:prstGeom>
+          <a:solidFill>
+            <a:srgbClr val="F1E6EF"/>
+          </a:solidFill>
+          <a:ln/>
+        </p:spPr>
+      </p:sp>
+      <p:sp>
+        <p:nvSpPr>
+          <p:cNvPr id="23" name="Text 21"/>
+          <p:cNvSpPr txBox="1"/>
+          <p:nvPr/>
+        </p:nvSpPr>
+        <p:spPr>
+          <a:xfrm>
+            <a:off x="7192264" y="3632200"/>
+            <a:ext cx="1178560" cy="889000"/>
+          </a:xfrm>
+          <a:prstGeom prst="rect">
+            <a:avLst/>
+          </a:prstGeom>
+          <a:noFill/>
+          <a:ln/>
+        </p:spPr>
+        <p:txBody>
+          <a:bodyPr wrap="square" lIns="0" tIns="0" rIns="0" bIns="0" rtlCol="0" anchor="ctr"/>
+          <a:lstStyle/>
+          <a:p>
+            <a:pPr indent="0" marL="0">
+              <a:buNone/>
+            </a:pPr>
+            <a:r>
+              <a:rPr lang="en-US" sz="1200" b="1" dirty="0">
+                <a:solidFill>
+                  <a:srgbClr val="1F1D21"/>
+                </a:solidFill>
+                <a:latin typeface="Times New Roman" pitchFamily="34" charset="0"/>
+                <a:ea typeface="Times New Roman" pitchFamily="34" charset="-122"/>
+                <a:cs typeface="Times New Roman" pitchFamily="34" charset="-120"/>
+              </a:rPr>
+              <a:t>Corrected labels</a:t>
+            </a:r>
+            <a:endParaRPr lang="en-US" sz="1200" dirty="0"/>
+          </a:p>
+        </p:txBody>
+      </p:sp>
+      <p:sp>
+        <p:nvSpPr>
+          <p:cNvPr id="24" name="Text 22"/>
+          <p:cNvSpPr txBox="1"/>
+          <p:nvPr/>
+        </p:nvSpPr>
+        <p:spPr>
+          <a:xfrm>
+            <a:off x="8462264" y="3632200"/>
+            <a:ext cx="1371600" cy="889000"/>
+          </a:xfrm>
+          <a:prstGeom prst="rect">
+            <a:avLst/>
+          </a:prstGeom>
+          <a:noFill/>
+          <a:ln/>
+        </p:spPr>
+        <p:txBody>
+          <a:bodyPr wrap="square" lIns="0" tIns="0" rIns="0" bIns="0" rtlCol="0" anchor="ctr"/>
+          <a:lstStyle/>
+          <a:p>
+            <a:pPr algn="ctr" indent="0" marL="0">
+              <a:buNone/>
+            </a:pPr>
+            <a:r>
+              <a:rPr lang="en-US" sz="1200" dirty="0">
+                <a:solidFill>
+                  <a:srgbClr val="1F1D21"/>
+                </a:solidFill>
+                <a:latin typeface="Times New Roman" pitchFamily="34" charset="0"/>
+                <a:ea typeface="Times New Roman" pitchFamily="34" charset="-122"/>
+                <a:cs typeface="Times New Roman" pitchFamily="34" charset="-120"/>
+              </a:rPr>
+              <a:t>[TODO]</a:t>
+            </a:r>
+            <a:endParaRPr lang="en-US" sz="1200" dirty="0"/>
+          </a:p>
+        </p:txBody>
+      </p:sp>
+      <p:sp>
+        <p:nvSpPr>
+          <p:cNvPr id="25" name="Text 23"/>
+          <p:cNvSpPr txBox="1"/>
+          <p:nvPr/>
+        </p:nvSpPr>
+        <p:spPr>
+          <a:xfrm>
+            <a:off x="9833864" y="3632200"/>
+            <a:ext cx="1371600" cy="889000"/>
+          </a:xfrm>
+          <a:prstGeom prst="rect">
+            <a:avLst/>
+          </a:prstGeom>
+          <a:noFill/>
+          <a:ln/>
+        </p:spPr>
+        <p:txBody>
+          <a:bodyPr wrap="square" lIns="0" tIns="0" rIns="0" bIns="0" rtlCol="0" anchor="ctr"/>
+          <a:lstStyle/>
+          <a:p>
+            <a:pPr algn="ctr" indent="0" marL="0">
+              <a:buNone/>
+            </a:pPr>
+            <a:r>
+              <a:rPr lang="en-US" sz="1200" dirty="0">
+                <a:solidFill>
+                  <a:srgbClr val="1F1D21"/>
+                </a:solidFill>
+                <a:latin typeface="Times New Roman" pitchFamily="34" charset="0"/>
+                <a:ea typeface="Times New Roman" pitchFamily="34" charset="-122"/>
+                <a:cs typeface="Times New Roman" pitchFamily="34" charset="-120"/>
+              </a:rPr>
+              <a:t>[TODO]</a:t>
+            </a:r>
+            <a:endParaRPr lang="en-US" sz="1200" dirty="0"/>
+          </a:p>
+        </p:txBody>
+      </p:sp>
+      <p:sp>
+        <p:nvSpPr>
+          <p:cNvPr id="26" name="Shape 24"/>
+          <p:cNvSpPr/>
+          <p:nvPr/>
+        </p:nvSpPr>
+        <p:spPr>
+          <a:xfrm>
+            <a:off x="7192264" y="4521200"/>
+            <a:ext cx="4013200" cy="9144"/>
+          </a:xfrm>
+          <a:prstGeom prst="rect">
+            <a:avLst/>
+          </a:prstGeom>
+          <a:solidFill>
+            <a:srgbClr val="E3E3E3"/>
+          </a:solidFill>
+          <a:ln/>
+        </p:spPr>
+      </p:sp>
+      <p:sp>
+        <p:nvSpPr>
+          <p:cNvPr id="27" name="Text 25"/>
+          <p:cNvSpPr txBox="1"/>
+          <p:nvPr/>
+        </p:nvSpPr>
+        <p:spPr>
+          <a:xfrm>
+            <a:off x="7192264" y="4673600"/>
+            <a:ext cx="4013200" cy="548640"/>
+          </a:xfrm>
+          <a:prstGeom prst="rect">
+            <a:avLst/>
+          </a:prstGeom>
+          <a:noFill/>
+          <a:ln/>
+        </p:spPr>
+        <p:txBody>
+          <a:bodyPr wrap="square" lIns="0" tIns="0" rIns="0" bIns="0" rtlCol="0" anchor="t"/>
+          <a:lstStyle/>
+          <a:p>
+            <a:pPr marL="177800" indent="-177800">
               <a:lnSpc>
-                <a:spcPct val="118000"/>
+                <a:spcPct val="115000"/>
               </a:lnSpc>
-              <a:buNone/>
-            </a:pPr>
-            <a:r>
-              <a:rPr lang="en-US" sz="1350" dirty="0">
+              <a:spcAft>
+                <a:spcPts val="500"/>
+              </a:spcAft>
+              <a:buSzPct val="100000"/>
+              <a:buChar char="▪"/>
+            </a:pPr>
+            <a:r>
+              <a:rPr lang="en-US" sz="1200" dirty="0">
                 <a:solidFill>
                   <a:srgbClr val="1F1D21"/>
                 </a:solidFill>
@@ -8495,15 +9095,15 @@
                 <a:ea typeface="Times New Roman" pitchFamily="34" charset="-122"/>
                 <a:cs typeface="Times New Roman" pitchFamily="34" charset="-120"/>
               </a:rPr>
-              <a:t>Trachea: 0.50</a:t>
-            </a:r>
-            <a:endParaRPr lang="en-US" sz="1350" dirty="0"/>
+              <a:t>[TODO] what changes with correction and with preprocessing</a:t>
+            </a:r>
+            <a:endParaRPr lang="en-US" sz="1200" dirty="0"/>
           </a:p>
         </p:txBody>
       </p:sp>
       <p:pic>
         <p:nvPicPr>
-          <p:cNvPr id="12" name="Image 0" descr="/Users/bellavg/ProjectsMSc/ai4mi_project/.claude/worktrees/segthor-presentation-midpoint-825c66/deck/assets/uva_logo.png">    </p:cNvPr>
+          <p:cNvPr id="28" name="Image 0" descr="/Users/bellavg/ProjectsMSc/ai4mi_project/.claude/worktrees/segthor-presentation-midpoint-825c66/deck/assets/uva_logo.png">    </p:cNvPr>
           <p:cNvPicPr>
             <a:picLocks noChangeAspect="1"/>
           </p:cNvPicPr>
@@ -8527,7 +9127,7 @@
       </p:pic>
       <p:sp>
         <p:nvSpPr>
-          <p:cNvPr id="13" name="Text 10"/>
+          <p:cNvPr id="29" name="Text 26"/>
           <p:cNvSpPr txBox="1"/>
           <p:nvPr/>
         </p:nvSpPr>

</xml_diff>